<commit_message>
docs(portfolio): 통합 검증 551건과 baseline 근거 갱신
</commit_message>
<xml_diff>
--- a/docs/portfolio/mulino-coreano-portfolio-ko.pptx
+++ b/docs/portfolio/mulino-coreano-portfolio-ko.pptx
@@ -2,26 +2,26 @@
 <file path=ppt/presentation.xml><?xml version="1.0" encoding="utf-8"?>
 <p:presentation xmlns:p="http://schemas.openxmlformats.org/presentationml/2006/main">
   <p:sldMasterIdLst>
-    <p:sldMasterId xmlns:r="http://schemas.openxmlformats.org/officeDocument/2006/relationships" id="2147483648" r:id="Rbcc3ce8e02624350"/>
+    <p:sldMasterId xmlns:r="http://schemas.openxmlformats.org/officeDocument/2006/relationships" id="2147483648" r:id="R8bac25ac660c44dc"/>
   </p:sldMasterIdLst>
   <p:notesMasterIdLst>
-    <p:notesMasterId xmlns:r="http://schemas.openxmlformats.org/officeDocument/2006/relationships" r:id="R470da54f270f46d3"/>
+    <p:notesMasterId xmlns:r="http://schemas.openxmlformats.org/officeDocument/2006/relationships" r:id="R9261039a96664751"/>
   </p:notesMasterIdLst>
   <p:sldIdLst>
-    <p:sldId xmlns:r="http://schemas.openxmlformats.org/officeDocument/2006/relationships" id="256" r:id="R5f7db1fd12b34d02"/>
-    <p:sldId xmlns:r="http://schemas.openxmlformats.org/officeDocument/2006/relationships" id="257" r:id="Re341e864a55040de"/>
-    <p:sldId xmlns:r="http://schemas.openxmlformats.org/officeDocument/2006/relationships" id="258" r:id="R33e1cc46d7de4a23"/>
-    <p:sldId xmlns:r="http://schemas.openxmlformats.org/officeDocument/2006/relationships" id="259" r:id="R4211de1264274184"/>
-    <p:sldId xmlns:r="http://schemas.openxmlformats.org/officeDocument/2006/relationships" id="260" r:id="Rb65a4de717224545"/>
-    <p:sldId xmlns:r="http://schemas.openxmlformats.org/officeDocument/2006/relationships" id="261" r:id="R82ae9c0a400d4691"/>
-    <p:sldId xmlns:r="http://schemas.openxmlformats.org/officeDocument/2006/relationships" id="262" r:id="R565800049ee14a04"/>
-    <p:sldId xmlns:r="http://schemas.openxmlformats.org/officeDocument/2006/relationships" id="263" r:id="R5364c025fc64432b"/>
-    <p:sldId xmlns:r="http://schemas.openxmlformats.org/officeDocument/2006/relationships" id="264" r:id="R7649be52d6c04857"/>
-    <p:sldId xmlns:r="http://schemas.openxmlformats.org/officeDocument/2006/relationships" id="265" r:id="R3230a30f10274602"/>
-    <p:sldId xmlns:r="http://schemas.openxmlformats.org/officeDocument/2006/relationships" id="266" r:id="Rb1f502b288524a12"/>
-    <p:sldId xmlns:r="http://schemas.openxmlformats.org/officeDocument/2006/relationships" id="267" r:id="R56e1d2e764344455"/>
-    <p:sldId xmlns:r="http://schemas.openxmlformats.org/officeDocument/2006/relationships" id="268" r:id="R0671c6c9f6c84410"/>
-    <p:sldId xmlns:r="http://schemas.openxmlformats.org/officeDocument/2006/relationships" id="269" r:id="R4ee60707e23a4e69"/>
+    <p:sldId xmlns:r="http://schemas.openxmlformats.org/officeDocument/2006/relationships" id="256" r:id="Rae107a6a45a34846"/>
+    <p:sldId xmlns:r="http://schemas.openxmlformats.org/officeDocument/2006/relationships" id="257" r:id="Rddd62883cc9a4169"/>
+    <p:sldId xmlns:r="http://schemas.openxmlformats.org/officeDocument/2006/relationships" id="258" r:id="Rb48144da15f242f8"/>
+    <p:sldId xmlns:r="http://schemas.openxmlformats.org/officeDocument/2006/relationships" id="259" r:id="Rca5d0f7e7d714083"/>
+    <p:sldId xmlns:r="http://schemas.openxmlformats.org/officeDocument/2006/relationships" id="260" r:id="R4652c4ef3f4a4827"/>
+    <p:sldId xmlns:r="http://schemas.openxmlformats.org/officeDocument/2006/relationships" id="261" r:id="R8c0b14575d584320"/>
+    <p:sldId xmlns:r="http://schemas.openxmlformats.org/officeDocument/2006/relationships" id="262" r:id="Ra392661835cd4b99"/>
+    <p:sldId xmlns:r="http://schemas.openxmlformats.org/officeDocument/2006/relationships" id="263" r:id="Rac448e6e721e4da3"/>
+    <p:sldId xmlns:r="http://schemas.openxmlformats.org/officeDocument/2006/relationships" id="264" r:id="Rc4fee66328704028"/>
+    <p:sldId xmlns:r="http://schemas.openxmlformats.org/officeDocument/2006/relationships" id="265" r:id="R1dbeee1b89ed4ea1"/>
+    <p:sldId xmlns:r="http://schemas.openxmlformats.org/officeDocument/2006/relationships" id="266" r:id="R3dd1e4229bf44ee6"/>
+    <p:sldId xmlns:r="http://schemas.openxmlformats.org/officeDocument/2006/relationships" id="267" r:id="Rc2b21a20447c4e2a"/>
+    <p:sldId xmlns:r="http://schemas.openxmlformats.org/officeDocument/2006/relationships" id="268" r:id="R60cbf2d887fc4bce"/>
+    <p:sldId xmlns:r="http://schemas.openxmlformats.org/officeDocument/2006/relationships" id="269" r:id="R4c58882b311c4595"/>
   </p:sldIdLst>
   <p:sldSz cx="12192000" cy="6858000"/>
   <p:notesSz cx="6858000" cy="9144000"/>
@@ -595,7 +595,7 @@
           <a:lstStyle xmlns:a="http://schemas.openxmlformats.org/drawingml/2006/main"/>
           <a:p xmlns:a="http://schemas.openxmlformats.org/drawingml/2006/main">
             <a:r>
-              <a:t>검증량은 업무 인수/규제 완전성을 뜻하지 않는다. Supplier 567 discovered -18 scenario discovery skips =549 executable passed, failures0 errors0. SIT current20=P2P6+QM6+RC6+restart2. Separate #44 tooling: MCP26 runner57 Zig7 CLI32. Final native source2d2a900 runner76/helper7/SIT20 pass, SIT before final logging-only Codex diagnostics. Full549 not repeated. Native acceptance incomplete. 출처: evidence.json 및 해시로 식별한 supplier/final-report.json, evidence/result.json. 원본 전체 로그는 coordinator 비공개 인수 bundle에 보존한다.</a:t>
+              <a:t>검증량은 업무 인수/규제 완전성을 뜻하지 않는다. Combined validated baseline fe6a51fadd2493018da59babd4a2eea908c2931f: clean test bootJar sitTest,569 discovered/18skip/551 executablePASS, failures0 errors0,20SITPASS/0fail/0skip,8m58s, modelcalls0, JARunchanged. Earlier Supplier0132 checkpoint567/18skip/549PASS remains historical. SIT20=P2P6+QM6+RC6+restart2. Separate #44 tooling: MCP26 runner57 Zig7 CLI32. Final native source2d2a900 runner76/helper7/SIT20 pass, SIT before final logging-only Codex diagnostics. Native worker did not repeat full549 at2d; subsequent combinedfe6 source passed551. Native acceptance remains incomplete. 출처: evidence.json 및 해시로 식별한 supplier/final-report.json, evidence/result.json. 원본 전체 로그는 coordinator 비공개 인수 bundle에 보존한다.</a:t>
             </a:r>
           </a:p>
         </p:txBody>
@@ -1433,7 +1433,7 @@
   </p:cSld>
   <p:clrMap bg1="lt1" tx1="dk1" bg2="lt2" tx2="dk2" accent1="accent1" accent2="accent2" accent3="accent3" accent4="accent4" accent5="accent5" accent6="accent6" hlink="hlink" folHlink="folHlink"/>
   <p:sldLayoutIdLst>
-    <p:sldLayoutId xmlns:r="http://schemas.openxmlformats.org/officeDocument/2006/relationships" id="2147483649" r:id="Re278db9a657941c0"/>
+    <p:sldLayoutId xmlns:r="http://schemas.openxmlformats.org/officeDocument/2006/relationships" id="2147483649" r:id="Rf11dea32bbf94ce1"/>
   </p:sldLayoutIdLst>
   <p:txStyles>
     <p:titleStyle>
@@ -2166,7 +2166,7 @@
           <p:cNvPr id="6" name="">
             <a:extLst xmlns:a="http://schemas.openxmlformats.org/drawingml/2006/main">
               <a:ext uri="{FF2B5EF4-FFF2-40B4-BE49-F238E27FC236}">
-                <a16:creationId xmlns:a16="http://schemas.microsoft.com/office/drawing/2014/main" id="{8799E9F7-6142-4E3A-8ED2-68FD95AEBFCA}"/>
+                <a16:creationId xmlns:a16="http://schemas.microsoft.com/office/drawing/2014/main" id="{83B1813B-456C-4CA8-B414-C0863F67151C}"/>
               </a:ext>
             </a:extLst>
           </p:cNvPr>
@@ -2223,7 +2223,7 @@
           <p:cNvPr id="2" name="">
             <a:extLst xmlns:a="http://schemas.openxmlformats.org/drawingml/2006/main">
               <a:ext uri="{FF2B5EF4-FFF2-40B4-BE49-F238E27FC236}">
-                <a16:creationId xmlns:a16="http://schemas.microsoft.com/office/drawing/2014/main" id="{44870D4A-872C-4C97-8DD3-96E9ED674A72}"/>
+                <a16:creationId xmlns:a16="http://schemas.microsoft.com/office/drawing/2014/main" id="{55379DB2-B05A-42BE-95B0-C111E39FFB62}"/>
               </a:ext>
             </a:extLst>
           </p:cNvPr>
@@ -2280,7 +2280,7 @@
           <p:cNvPr id="3" name="">
             <a:extLst xmlns:a="http://schemas.openxmlformats.org/drawingml/2006/main">
               <a:ext uri="{FF2B5EF4-FFF2-40B4-BE49-F238E27FC236}">
-                <a16:creationId xmlns:a16="http://schemas.microsoft.com/office/drawing/2014/main" id="{16BE941E-4E80-4B9B-A9DC-80F6AAAE8578}"/>
+                <a16:creationId xmlns:a16="http://schemas.microsoft.com/office/drawing/2014/main" id="{7BBF4012-0D4C-4AAA-B9A9-C71F8E59F507}"/>
               </a:ext>
             </a:extLst>
           </p:cNvPr>
@@ -2360,7 +2360,7 @@
           <p:cNvPr id="4" name="">
             <a:extLst xmlns:a="http://schemas.openxmlformats.org/drawingml/2006/main">
               <a:ext uri="{FF2B5EF4-FFF2-40B4-BE49-F238E27FC236}">
-                <a16:creationId xmlns:a16="http://schemas.microsoft.com/office/drawing/2014/main" id="{88BADEEA-6B74-4625-8222-764896828B56}"/>
+                <a16:creationId xmlns:a16="http://schemas.microsoft.com/office/drawing/2014/main" id="{5801D255-BEF4-47FD-B195-825638A025CC}"/>
               </a:ext>
             </a:extLst>
           </p:cNvPr>
@@ -2417,7 +2417,7 @@
           <p:cNvPr id="5" name="">
             <a:extLst xmlns:a="http://schemas.openxmlformats.org/drawingml/2006/main">
               <a:ext uri="{FF2B5EF4-FFF2-40B4-BE49-F238E27FC236}">
-                <a16:creationId xmlns:a16="http://schemas.microsoft.com/office/drawing/2014/main" id="{9C1DF49D-75A9-45B1-B11D-F2536ABCE7B0}"/>
+                <a16:creationId xmlns:a16="http://schemas.microsoft.com/office/drawing/2014/main" id="{8B0E8176-BB2E-4524-AE7D-505CF7A95358}"/>
               </a:ext>
             </a:extLst>
           </p:cNvPr>
@@ -2472,7 +2472,7 @@
     </p:spTree>
     <p:extLst>
       <p:ext uri="{BB962C8B-B14F-4D97-AF65-F5344CB8AC3E}">
-        <p14:creationId xmlns:p14="http://schemas.microsoft.com/office/powerpoint/2010/main" val="1957195764"/>
+        <p14:creationId xmlns:p14="http://schemas.microsoft.com/office/powerpoint/2010/main" val="112517984"/>
       </p:ext>
     </p:extLst>
   </p:cSld>
@@ -2503,7 +2503,7 @@
           <p:cNvPr id="5" name="">
             <a:extLst xmlns:a="http://schemas.openxmlformats.org/drawingml/2006/main">
               <a:ext uri="{FF2B5EF4-FFF2-40B4-BE49-F238E27FC236}">
-                <a16:creationId xmlns:a16="http://schemas.microsoft.com/office/drawing/2014/main" id="{13AF8638-125B-4166-B86B-618CE81F58D8}"/>
+                <a16:creationId xmlns:a16="http://schemas.microsoft.com/office/drawing/2014/main" id="{2B299F5E-3B24-4EF0-9F4A-CA907E30A34C}"/>
               </a:ext>
             </a:extLst>
           </p:cNvPr>
@@ -2560,7 +2560,7 @@
           <p:cNvPr id="2" name="">
             <a:extLst xmlns:a="http://schemas.openxmlformats.org/drawingml/2006/main">
               <a:ext uri="{FF2B5EF4-FFF2-40B4-BE49-F238E27FC236}">
-                <a16:creationId xmlns:a16="http://schemas.microsoft.com/office/drawing/2014/main" id="{FFFC5975-A056-4DFF-970C-D67CF4991F09}"/>
+                <a16:creationId xmlns:a16="http://schemas.microsoft.com/office/drawing/2014/main" id="{7ED31914-CF8B-4D15-B803-1D1BB4FC2367}"/>
               </a:ext>
             </a:extLst>
           </p:cNvPr>
@@ -3084,7 +3084,7 @@
           <p:cNvPr id="4" name="">
             <a:extLst xmlns:a="http://schemas.openxmlformats.org/drawingml/2006/main">
               <a:ext uri="{FF2B5EF4-FFF2-40B4-BE49-F238E27FC236}">
-                <a16:creationId xmlns:a16="http://schemas.microsoft.com/office/drawing/2014/main" id="{1FF209C7-87FD-4531-98EF-9DD05BBEC26E}"/>
+                <a16:creationId xmlns:a16="http://schemas.microsoft.com/office/drawing/2014/main" id="{84ADD6BA-8CB2-4EAF-B3FF-2B697C2CFCD3}"/>
               </a:ext>
             </a:extLst>
           </p:cNvPr>
@@ -3139,7 +3139,7 @@
     </p:spTree>
     <p:extLst>
       <p:ext uri="{BB962C8B-B14F-4D97-AF65-F5344CB8AC3E}">
-        <p14:creationId xmlns:p14="http://schemas.microsoft.com/office/powerpoint/2010/main" val="2007796444"/>
+        <p14:creationId xmlns:p14="http://schemas.microsoft.com/office/powerpoint/2010/main" val="196152736"/>
       </p:ext>
     </p:extLst>
   </p:cSld>
@@ -3170,7 +3170,7 @@
           <p:cNvPr id="9" name="">
             <a:extLst xmlns:a="http://schemas.openxmlformats.org/drawingml/2006/main">
               <a:ext uri="{FF2B5EF4-FFF2-40B4-BE49-F238E27FC236}">
-                <a16:creationId xmlns:a16="http://schemas.microsoft.com/office/drawing/2014/main" id="{6669A4FF-A07C-4ADE-AED1-360A82C29790}"/>
+                <a16:creationId xmlns:a16="http://schemas.microsoft.com/office/drawing/2014/main" id="{346E57D7-82AB-46DA-96EF-EB6804144F8C}"/>
               </a:ext>
             </a:extLst>
           </p:cNvPr>
@@ -3227,7 +3227,7 @@
           <p:cNvPr id="2" name="">
             <a:extLst xmlns:a="http://schemas.openxmlformats.org/drawingml/2006/main">
               <a:ext uri="{FF2B5EF4-FFF2-40B4-BE49-F238E27FC236}">
-                <a16:creationId xmlns:a16="http://schemas.microsoft.com/office/drawing/2014/main" id="{6A45095A-5C31-489E-8967-D38B060C6E16}"/>
+                <a16:creationId xmlns:a16="http://schemas.microsoft.com/office/drawing/2014/main" id="{E43496C1-9D48-4FE6-AA32-9F62FC228D30}"/>
               </a:ext>
             </a:extLst>
           </p:cNvPr>
@@ -3291,7 +3291,7 @@
         </p:xfrm>
         <a:graphic xmlns:a="http://schemas.openxmlformats.org/drawingml/2006/main">
           <a:graphicData uri="http://schemas.openxmlformats.org/drawingml/2006/chart">
-            <c:chart xmlns:r="http://schemas.openxmlformats.org/officeDocument/2006/relationships" xmlns:c="http://schemas.openxmlformats.org/drawingml/2006/chart" r:id="R7bae05097eea4661"/>
+            <c:chart xmlns:r="http://schemas.openxmlformats.org/officeDocument/2006/relationships" xmlns:c="http://schemas.openxmlformats.org/drawingml/2006/chart" r:id="R3e2350a5ef274369"/>
           </a:graphicData>
         </a:graphic>
       </p:graphicFrame>
@@ -3300,7 +3300,7 @@
           <p:cNvPr id="4" name="">
             <a:extLst xmlns:a="http://schemas.openxmlformats.org/drawingml/2006/main">
               <a:ext uri="{FF2B5EF4-FFF2-40B4-BE49-F238E27FC236}">
-                <a16:creationId xmlns:a16="http://schemas.microsoft.com/office/drawing/2014/main" id="{A2E9918C-A8E1-4EC6-98D5-80EAA1A2F5EC}"/>
+                <a16:creationId xmlns:a16="http://schemas.microsoft.com/office/drawing/2014/main" id="{E3F4978A-3FFB-416A-BA79-CF9CA5879ED3}"/>
               </a:ext>
             </a:extLst>
           </p:cNvPr>
@@ -3347,7 +3347,7 @@
                 <a:ea typeface="Apple SD Gothic Neo"/>
                 <a:cs typeface="Apple SD Gothic Neo"/>
               </a:rPr>
-              <a:t>549건 실행 통과</a:t>
+              <a:t>551건 실행 통과</a:t>
             </a:r>
           </a:p>
         </p:txBody>
@@ -3357,7 +3357,7 @@
           <p:cNvPr id="5" name="">
             <a:extLst xmlns:a="http://schemas.openxmlformats.org/drawingml/2006/main">
               <a:ext uri="{FF2B5EF4-FFF2-40B4-BE49-F238E27FC236}">
-                <a16:creationId xmlns:a16="http://schemas.microsoft.com/office/drawing/2014/main" id="{8D0D8402-2164-4F08-B525-26C8CE3BD330}"/>
+                <a16:creationId xmlns:a16="http://schemas.microsoft.com/office/drawing/2014/main" id="{37FEAFCD-6C4B-4562-A779-9CEAD8137974}"/>
               </a:ext>
             </a:extLst>
           </p:cNvPr>
@@ -3404,7 +3404,7 @@
                 <a:ea typeface="Apple SD Gothic Neo"/>
                 <a:cs typeface="Apple SD Gothic Neo"/>
               </a:rPr>
-              <a:t>567건 발견 / 18건 skip</a:t>
+              <a:t>569건 발견 / 18건 skip</a:t>
             </a:r>
           </a:p>
           <a:p xmlns:a="http://schemas.openxmlformats.org/drawingml/2006/main">
@@ -3427,7 +3427,7 @@
                 <a:ea typeface="Apple SD Gothic Neo"/>
                 <a:cs typeface="Apple SD Gothic Neo"/>
               </a:rPr>
-              <a:t>Supplier 기준 최신 source</a:t>
+              <a:t>통합 검증 baseline fe6a51f</a:t>
             </a:r>
           </a:p>
         </p:txBody>
@@ -3437,7 +3437,7 @@
           <p:cNvPr id="6" name="">
             <a:extLst xmlns:a="http://schemas.openxmlformats.org/drawingml/2006/main">
               <a:ext uri="{FF2B5EF4-FFF2-40B4-BE49-F238E27FC236}">
-                <a16:creationId xmlns:a16="http://schemas.microsoft.com/office/drawing/2014/main" id="{DA336E77-0217-42BB-97C2-AB8B140B7B6B}"/>
+                <a16:creationId xmlns:a16="http://schemas.microsoft.com/office/drawing/2014/main" id="{9BDD8E45-6297-4CE8-BAFB-A608073B42DA}"/>
               </a:ext>
             </a:extLst>
           </p:cNvPr>
@@ -3494,7 +3494,7 @@
           <p:cNvPr id="7" name="">
             <a:extLst xmlns:a="http://schemas.openxmlformats.org/drawingml/2006/main">
               <a:ext uri="{FF2B5EF4-FFF2-40B4-BE49-F238E27FC236}">
-                <a16:creationId xmlns:a16="http://schemas.microsoft.com/office/drawing/2014/main" id="{A4CE9346-6923-4163-821F-F3B292A77C80}"/>
+                <a16:creationId xmlns:a16="http://schemas.microsoft.com/office/drawing/2014/main" id="{880D353F-A894-46B3-BF73-ACDA1D618225}"/>
               </a:ext>
             </a:extLst>
           </p:cNvPr>
@@ -3597,7 +3597,7 @@
           <p:cNvPr id="8" name="">
             <a:extLst xmlns:a="http://schemas.openxmlformats.org/drawingml/2006/main">
               <a:ext uri="{FF2B5EF4-FFF2-40B4-BE49-F238E27FC236}">
-                <a16:creationId xmlns:a16="http://schemas.microsoft.com/office/drawing/2014/main" id="{5D72A8EF-BD2E-4BA6-94BD-CEB607647BE5}"/>
+                <a16:creationId xmlns:a16="http://schemas.microsoft.com/office/drawing/2014/main" id="{20EB83D8-0315-4702-AA60-28D3F5AC4699}"/>
               </a:ext>
             </a:extLst>
           </p:cNvPr>
@@ -3652,7 +3652,7 @@
     </p:spTree>
     <p:extLst>
       <p:ext uri="{BB962C8B-B14F-4D97-AF65-F5344CB8AC3E}">
-        <p14:creationId xmlns:p14="http://schemas.microsoft.com/office/powerpoint/2010/main" val="1552606471"/>
+        <p14:creationId xmlns:p14="http://schemas.microsoft.com/office/powerpoint/2010/main" val="1618333756"/>
       </p:ext>
     </p:extLst>
   </p:cSld>
@@ -3683,7 +3683,7 @@
           <p:cNvPr id="5" name="">
             <a:extLst xmlns:a="http://schemas.openxmlformats.org/drawingml/2006/main">
               <a:ext uri="{FF2B5EF4-FFF2-40B4-BE49-F238E27FC236}">
-                <a16:creationId xmlns:a16="http://schemas.microsoft.com/office/drawing/2014/main" id="{4AF621A8-27CC-456D-9F5F-A4E81C112F12}"/>
+                <a16:creationId xmlns:a16="http://schemas.microsoft.com/office/drawing/2014/main" id="{E27104DE-255C-4AE6-A2B7-2D627E67B45A}"/>
               </a:ext>
             </a:extLst>
           </p:cNvPr>
@@ -3740,7 +3740,7 @@
           <p:cNvPr id="2" name="">
             <a:extLst xmlns:a="http://schemas.openxmlformats.org/drawingml/2006/main">
               <a:ext uri="{FF2B5EF4-FFF2-40B4-BE49-F238E27FC236}">
-                <a16:creationId xmlns:a16="http://schemas.microsoft.com/office/drawing/2014/main" id="{B31AD3CB-B521-4612-B19C-926CC3ACDB1E}"/>
+                <a16:creationId xmlns:a16="http://schemas.microsoft.com/office/drawing/2014/main" id="{51E1A2F1-E1CC-4120-972D-7DC6EA10A2A7}"/>
               </a:ext>
             </a:extLst>
           </p:cNvPr>
@@ -4338,7 +4338,7 @@
           <p:cNvPr id="4" name="">
             <a:extLst xmlns:a="http://schemas.openxmlformats.org/drawingml/2006/main">
               <a:ext uri="{FF2B5EF4-FFF2-40B4-BE49-F238E27FC236}">
-                <a16:creationId xmlns:a16="http://schemas.microsoft.com/office/drawing/2014/main" id="{73D5F753-F692-436F-B035-89126717922F}"/>
+                <a16:creationId xmlns:a16="http://schemas.microsoft.com/office/drawing/2014/main" id="{B54EDD01-3F79-4C84-B091-47AAD568FCD7}"/>
               </a:ext>
             </a:extLst>
           </p:cNvPr>
@@ -4393,7 +4393,7 @@
     </p:spTree>
     <p:extLst>
       <p:ext uri="{BB962C8B-B14F-4D97-AF65-F5344CB8AC3E}">
-        <p14:creationId xmlns:p14="http://schemas.microsoft.com/office/powerpoint/2010/main" val="302678"/>
+        <p14:creationId xmlns:p14="http://schemas.microsoft.com/office/powerpoint/2010/main" val="175329987"/>
       </p:ext>
     </p:extLst>
   </p:cSld>
@@ -4424,7 +4424,7 @@
           <p:cNvPr id="10" name="">
             <a:extLst xmlns:a="http://schemas.openxmlformats.org/drawingml/2006/main">
               <a:ext uri="{FF2B5EF4-FFF2-40B4-BE49-F238E27FC236}">
-                <a16:creationId xmlns:a16="http://schemas.microsoft.com/office/drawing/2014/main" id="{72F8A784-0717-4E22-B958-561B6786750B}"/>
+                <a16:creationId xmlns:a16="http://schemas.microsoft.com/office/drawing/2014/main" id="{917AF00A-3507-408A-8060-C6B6B6E62BCD}"/>
               </a:ext>
             </a:extLst>
           </p:cNvPr>
@@ -4481,7 +4481,7 @@
           <p:cNvPr id="2" name="">
             <a:extLst xmlns:a="http://schemas.openxmlformats.org/drawingml/2006/main">
               <a:ext uri="{FF2B5EF4-FFF2-40B4-BE49-F238E27FC236}">
-                <a16:creationId xmlns:a16="http://schemas.microsoft.com/office/drawing/2014/main" id="{BA6B2FFD-19F8-42C3-9299-349023A5B2F7}"/>
+                <a16:creationId xmlns:a16="http://schemas.microsoft.com/office/drawing/2014/main" id="{5D4C2AAC-6DB7-4A54-9079-40D33CCF5923}"/>
               </a:ext>
             </a:extLst>
           </p:cNvPr>
@@ -4538,7 +4538,7 @@
           <p:cNvPr id="3" name="">
             <a:extLst xmlns:a="http://schemas.openxmlformats.org/drawingml/2006/main">
               <a:ext uri="{FF2B5EF4-FFF2-40B4-BE49-F238E27FC236}">
-                <a16:creationId xmlns:a16="http://schemas.microsoft.com/office/drawing/2014/main" id="{3F742531-D99D-4550-B3BD-3C145A51D664}"/>
+                <a16:creationId xmlns:a16="http://schemas.microsoft.com/office/drawing/2014/main" id="{8AE81CF3-E2ED-41D7-B43F-88DBE515193F}"/>
               </a:ext>
             </a:extLst>
           </p:cNvPr>
@@ -4595,7 +4595,7 @@
           <p:cNvPr id="4" name="">
             <a:extLst xmlns:a="http://schemas.openxmlformats.org/drawingml/2006/main">
               <a:ext uri="{FF2B5EF4-FFF2-40B4-BE49-F238E27FC236}">
-                <a16:creationId xmlns:a16="http://schemas.microsoft.com/office/drawing/2014/main" id="{A5C66684-416F-40EE-B5E4-1C26615AF0F5}"/>
+                <a16:creationId xmlns:a16="http://schemas.microsoft.com/office/drawing/2014/main" id="{120298AC-C386-480F-BD76-31B75F4B198D}"/>
               </a:ext>
             </a:extLst>
           </p:cNvPr>
@@ -4652,7 +4652,7 @@
           <p:cNvPr id="5" name="">
             <a:extLst xmlns:a="http://schemas.openxmlformats.org/drawingml/2006/main">
               <a:ext uri="{FF2B5EF4-FFF2-40B4-BE49-F238E27FC236}">
-                <a16:creationId xmlns:a16="http://schemas.microsoft.com/office/drawing/2014/main" id="{BBCAB269-72E4-45B0-8AA7-D5E442FEFB66}"/>
+                <a16:creationId xmlns:a16="http://schemas.microsoft.com/office/drawing/2014/main" id="{C5A01BCF-1274-4BBF-A772-081D66A694B4}"/>
               </a:ext>
             </a:extLst>
           </p:cNvPr>
@@ -4709,7 +4709,7 @@
           <p:cNvPr id="6" name="">
             <a:extLst xmlns:a="http://schemas.openxmlformats.org/drawingml/2006/main">
               <a:ext uri="{FF2B5EF4-FFF2-40B4-BE49-F238E27FC236}">
-                <a16:creationId xmlns:a16="http://schemas.microsoft.com/office/drawing/2014/main" id="{A2DE3CDA-D212-43A1-BFBD-F94FAB3C55D4}"/>
+                <a16:creationId xmlns:a16="http://schemas.microsoft.com/office/drawing/2014/main" id="{90B7B633-1390-4E5F-A7AF-AB345BCA9B3A}"/>
               </a:ext>
             </a:extLst>
           </p:cNvPr>
@@ -4766,7 +4766,7 @@
           <p:cNvPr id="7" name="">
             <a:extLst xmlns:a="http://schemas.openxmlformats.org/drawingml/2006/main">
               <a:ext uri="{FF2B5EF4-FFF2-40B4-BE49-F238E27FC236}">
-                <a16:creationId xmlns:a16="http://schemas.microsoft.com/office/drawing/2014/main" id="{D569291D-EC9C-4A90-A963-78426FC32AD3}"/>
+                <a16:creationId xmlns:a16="http://schemas.microsoft.com/office/drawing/2014/main" id="{04ABA4DB-ACB6-498F-BF83-2CE2D75C4F2F}"/>
               </a:ext>
             </a:extLst>
           </p:cNvPr>
@@ -4823,7 +4823,7 @@
           <p:cNvPr id="8" name="">
             <a:extLst xmlns:a="http://schemas.openxmlformats.org/drawingml/2006/main">
               <a:ext uri="{FF2B5EF4-FFF2-40B4-BE49-F238E27FC236}">
-                <a16:creationId xmlns:a16="http://schemas.microsoft.com/office/drawing/2014/main" id="{96C2B4B2-DA46-4201-8856-00BBE57FB4CF}"/>
+                <a16:creationId xmlns:a16="http://schemas.microsoft.com/office/drawing/2014/main" id="{7FEEB52F-B43F-418F-868D-9EAA7DAF98F7}"/>
               </a:ext>
             </a:extLst>
           </p:cNvPr>
@@ -4880,7 +4880,7 @@
           <p:cNvPr id="9" name="">
             <a:extLst xmlns:a="http://schemas.openxmlformats.org/drawingml/2006/main">
               <a:ext uri="{FF2B5EF4-FFF2-40B4-BE49-F238E27FC236}">
-                <a16:creationId xmlns:a16="http://schemas.microsoft.com/office/drawing/2014/main" id="{F376C74C-CF54-4EF6-9225-1A96BD9C398D}"/>
+                <a16:creationId xmlns:a16="http://schemas.microsoft.com/office/drawing/2014/main" id="{2BDBB6DB-8A92-4FD0-B90D-3C92AE3BE3E7}"/>
               </a:ext>
             </a:extLst>
           </p:cNvPr>
@@ -4935,7 +4935,7 @@
     </p:spTree>
     <p:extLst>
       <p:ext uri="{BB962C8B-B14F-4D97-AF65-F5344CB8AC3E}">
-        <p14:creationId xmlns:p14="http://schemas.microsoft.com/office/powerpoint/2010/main" val="1963465298"/>
+        <p14:creationId xmlns:p14="http://schemas.microsoft.com/office/powerpoint/2010/main" val="472536300"/>
       </p:ext>
     </p:extLst>
   </p:cSld>
@@ -4966,7 +4966,7 @@
           <p:cNvPr id="10" name="">
             <a:extLst xmlns:a="http://schemas.openxmlformats.org/drawingml/2006/main">
               <a:ext uri="{FF2B5EF4-FFF2-40B4-BE49-F238E27FC236}">
-                <a16:creationId xmlns:a16="http://schemas.microsoft.com/office/drawing/2014/main" id="{4C7316EA-2760-4BFC-B7FE-0CCE40E6F000}"/>
+                <a16:creationId xmlns:a16="http://schemas.microsoft.com/office/drawing/2014/main" id="{16A50DCA-89D4-4D5C-9B26-078F946CEF79}"/>
               </a:ext>
             </a:extLst>
           </p:cNvPr>
@@ -5023,7 +5023,7 @@
           <p:cNvPr id="2" name="">
             <a:extLst xmlns:a="http://schemas.openxmlformats.org/drawingml/2006/main">
               <a:ext uri="{FF2B5EF4-FFF2-40B4-BE49-F238E27FC236}">
-                <a16:creationId xmlns:a16="http://schemas.microsoft.com/office/drawing/2014/main" id="{0B18700B-C7D3-4A66-8F7D-B6BC99E19B23}"/>
+                <a16:creationId xmlns:a16="http://schemas.microsoft.com/office/drawing/2014/main" id="{3EEDDCA2-6CA6-4401-AFFE-B3EE405516F6}"/>
               </a:ext>
             </a:extLst>
           </p:cNvPr>
@@ -5080,7 +5080,7 @@
           <p:cNvPr id="3" name="">
             <a:extLst xmlns:a="http://schemas.openxmlformats.org/drawingml/2006/main">
               <a:ext uri="{FF2B5EF4-FFF2-40B4-BE49-F238E27FC236}">
-                <a16:creationId xmlns:a16="http://schemas.microsoft.com/office/drawing/2014/main" id="{D574AB4E-9650-4AC0-AF00-990EBA94201B}"/>
+                <a16:creationId xmlns:a16="http://schemas.microsoft.com/office/drawing/2014/main" id="{BFE25ADD-4D9D-4103-B124-99057534DE7E}"/>
               </a:ext>
             </a:extLst>
           </p:cNvPr>
@@ -5137,7 +5137,7 @@
           <p:cNvPr id="4" name="">
             <a:extLst xmlns:a="http://schemas.openxmlformats.org/drawingml/2006/main">
               <a:ext uri="{FF2B5EF4-FFF2-40B4-BE49-F238E27FC236}">
-                <a16:creationId xmlns:a16="http://schemas.microsoft.com/office/drawing/2014/main" id="{43D2F1ED-F537-41B6-8825-19FC861E2108}"/>
+                <a16:creationId xmlns:a16="http://schemas.microsoft.com/office/drawing/2014/main" id="{427B912E-42BE-4414-A9FC-1F546766C138}"/>
               </a:ext>
             </a:extLst>
           </p:cNvPr>
@@ -5194,7 +5194,7 @@
           <p:cNvPr id="5" name="">
             <a:extLst xmlns:a="http://schemas.openxmlformats.org/drawingml/2006/main">
               <a:ext uri="{FF2B5EF4-FFF2-40B4-BE49-F238E27FC236}">
-                <a16:creationId xmlns:a16="http://schemas.microsoft.com/office/drawing/2014/main" id="{F0842A37-3BE8-42A9-A584-C37064C97C1E}"/>
+                <a16:creationId xmlns:a16="http://schemas.microsoft.com/office/drawing/2014/main" id="{FAB88058-385F-45C5-8E8F-229495F96B64}"/>
               </a:ext>
             </a:extLst>
           </p:cNvPr>
@@ -5251,7 +5251,7 @@
           <p:cNvPr id="6" name="">
             <a:extLst xmlns:a="http://schemas.openxmlformats.org/drawingml/2006/main">
               <a:ext uri="{FF2B5EF4-FFF2-40B4-BE49-F238E27FC236}">
-                <a16:creationId xmlns:a16="http://schemas.microsoft.com/office/drawing/2014/main" id="{999D2113-647A-46E3-97A4-11CEF0E3F8CB}"/>
+                <a16:creationId xmlns:a16="http://schemas.microsoft.com/office/drawing/2014/main" id="{C4B92BD7-F0D5-4E65-BE5F-9318F89BF175}"/>
               </a:ext>
             </a:extLst>
           </p:cNvPr>
@@ -5308,7 +5308,7 @@
           <p:cNvPr id="7" name="">
             <a:extLst xmlns:a="http://schemas.openxmlformats.org/drawingml/2006/main">
               <a:ext uri="{FF2B5EF4-FFF2-40B4-BE49-F238E27FC236}">
-                <a16:creationId xmlns:a16="http://schemas.microsoft.com/office/drawing/2014/main" id="{3CD76AE9-4AEE-4850-8F33-92D0B18938D7}"/>
+                <a16:creationId xmlns:a16="http://schemas.microsoft.com/office/drawing/2014/main" id="{C800B5C8-6BC3-4895-B99C-026E3F8D40A3}"/>
               </a:ext>
             </a:extLst>
           </p:cNvPr>
@@ -5365,7 +5365,7 @@
           <p:cNvPr id="8" name="">
             <a:extLst xmlns:a="http://schemas.openxmlformats.org/drawingml/2006/main">
               <a:ext uri="{FF2B5EF4-FFF2-40B4-BE49-F238E27FC236}">
-                <a16:creationId xmlns:a16="http://schemas.microsoft.com/office/drawing/2014/main" id="{ED7B8A03-F1A8-4DDA-8D8E-29F3B37BD804}"/>
+                <a16:creationId xmlns:a16="http://schemas.microsoft.com/office/drawing/2014/main" id="{4F68ADF3-AD11-4EBA-93E0-F63BA2875579}"/>
               </a:ext>
             </a:extLst>
           </p:cNvPr>
@@ -5422,7 +5422,7 @@
           <p:cNvPr id="9" name="">
             <a:extLst xmlns:a="http://schemas.openxmlformats.org/drawingml/2006/main">
               <a:ext uri="{FF2B5EF4-FFF2-40B4-BE49-F238E27FC236}">
-                <a16:creationId xmlns:a16="http://schemas.microsoft.com/office/drawing/2014/main" id="{D5569BF2-DB5D-4F92-A50D-70386AD6F236}"/>
+                <a16:creationId xmlns:a16="http://schemas.microsoft.com/office/drawing/2014/main" id="{2061828C-4393-4C08-ACDA-9A0745ACAF54}"/>
               </a:ext>
             </a:extLst>
           </p:cNvPr>
@@ -5477,7 +5477,7 @@
     </p:spTree>
     <p:extLst>
       <p:ext uri="{BB962C8B-B14F-4D97-AF65-F5344CB8AC3E}">
-        <p14:creationId xmlns:p14="http://schemas.microsoft.com/office/powerpoint/2010/main" val="1932185867"/>
+        <p14:creationId xmlns:p14="http://schemas.microsoft.com/office/powerpoint/2010/main" val="375168767"/>
       </p:ext>
     </p:extLst>
   </p:cSld>
@@ -5508,7 +5508,7 @@
           <p:cNvPr id="5" name="">
             <a:extLst xmlns:a="http://schemas.openxmlformats.org/drawingml/2006/main">
               <a:ext uri="{FF2B5EF4-FFF2-40B4-BE49-F238E27FC236}">
-                <a16:creationId xmlns:a16="http://schemas.microsoft.com/office/drawing/2014/main" id="{57C5651F-D85C-4A0D-B991-428C31136075}"/>
+                <a16:creationId xmlns:a16="http://schemas.microsoft.com/office/drawing/2014/main" id="{12DCFE49-CE2A-4673-92F9-DC3BEEA645E1}"/>
               </a:ext>
             </a:extLst>
           </p:cNvPr>
@@ -5565,7 +5565,7 @@
           <p:cNvPr id="2" name="">
             <a:extLst xmlns:a="http://schemas.openxmlformats.org/drawingml/2006/main">
               <a:ext uri="{FF2B5EF4-FFF2-40B4-BE49-F238E27FC236}">
-                <a16:creationId xmlns:a16="http://schemas.microsoft.com/office/drawing/2014/main" id="{F63824D1-8C53-4263-8EE1-BE0CD941B906}"/>
+                <a16:creationId xmlns:a16="http://schemas.microsoft.com/office/drawing/2014/main" id="{4440468F-C1D2-400E-B196-82FB0C4FFCB4}"/>
               </a:ext>
             </a:extLst>
           </p:cNvPr>
@@ -6089,7 +6089,7 @@
           <p:cNvPr id="4" name="">
             <a:extLst xmlns:a="http://schemas.openxmlformats.org/drawingml/2006/main">
               <a:ext uri="{FF2B5EF4-FFF2-40B4-BE49-F238E27FC236}">
-                <a16:creationId xmlns:a16="http://schemas.microsoft.com/office/drawing/2014/main" id="{3D5FE85B-2B92-4868-B72A-1F125755F541}"/>
+                <a16:creationId xmlns:a16="http://schemas.microsoft.com/office/drawing/2014/main" id="{0010B7AC-9C2B-410C-BC04-4A3378653A6D}"/>
               </a:ext>
             </a:extLst>
           </p:cNvPr>
@@ -6144,7 +6144,7 @@
     </p:spTree>
     <p:extLst>
       <p:ext uri="{BB962C8B-B14F-4D97-AF65-F5344CB8AC3E}">
-        <p14:creationId xmlns:p14="http://schemas.microsoft.com/office/powerpoint/2010/main" val="904963157"/>
+        <p14:creationId xmlns:p14="http://schemas.microsoft.com/office/powerpoint/2010/main" val="857906691"/>
       </p:ext>
     </p:extLst>
   </p:cSld>
@@ -6175,7 +6175,7 @@
           <p:cNvPr id="5" name="">
             <a:extLst xmlns:a="http://schemas.openxmlformats.org/drawingml/2006/main">
               <a:ext uri="{FF2B5EF4-FFF2-40B4-BE49-F238E27FC236}">
-                <a16:creationId xmlns:a16="http://schemas.microsoft.com/office/drawing/2014/main" id="{D5A6BA8C-BF56-40A4-A1D9-2CAAE4828A7F}"/>
+                <a16:creationId xmlns:a16="http://schemas.microsoft.com/office/drawing/2014/main" id="{7D46FA23-1927-4E8E-846F-CC699CBDDA75}"/>
               </a:ext>
             </a:extLst>
           </p:cNvPr>
@@ -6232,7 +6232,7 @@
           <p:cNvPr id="2" name="">
             <a:extLst xmlns:a="http://schemas.openxmlformats.org/drawingml/2006/main">
               <a:ext uri="{FF2B5EF4-FFF2-40B4-BE49-F238E27FC236}">
-                <a16:creationId xmlns:a16="http://schemas.microsoft.com/office/drawing/2014/main" id="{EF27FB19-848B-4BAF-82F3-DBF28B9301BF}"/>
+                <a16:creationId xmlns:a16="http://schemas.microsoft.com/office/drawing/2014/main" id="{C658177E-39EE-4384-A9FB-1FBF05160E2D}"/>
               </a:ext>
             </a:extLst>
           </p:cNvPr>
@@ -6830,7 +6830,7 @@
           <p:cNvPr id="4" name="">
             <a:extLst xmlns:a="http://schemas.openxmlformats.org/drawingml/2006/main">
               <a:ext uri="{FF2B5EF4-FFF2-40B4-BE49-F238E27FC236}">
-                <a16:creationId xmlns:a16="http://schemas.microsoft.com/office/drawing/2014/main" id="{25EC8ADE-2BA7-46A8-ADD7-0D1F01509FC4}"/>
+                <a16:creationId xmlns:a16="http://schemas.microsoft.com/office/drawing/2014/main" id="{165E0374-0F5A-41A7-AAF9-E9F060F8BC9D}"/>
               </a:ext>
             </a:extLst>
           </p:cNvPr>
@@ -6885,7 +6885,7 @@
     </p:spTree>
     <p:extLst>
       <p:ext uri="{BB962C8B-B14F-4D97-AF65-F5344CB8AC3E}">
-        <p14:creationId xmlns:p14="http://schemas.microsoft.com/office/powerpoint/2010/main" val="84698760"/>
+        <p14:creationId xmlns:p14="http://schemas.microsoft.com/office/powerpoint/2010/main" val="197027452"/>
       </p:ext>
     </p:extLst>
   </p:cSld>
@@ -6916,7 +6916,7 @@
           <p:cNvPr id="13" name="">
             <a:extLst xmlns:a="http://schemas.openxmlformats.org/drawingml/2006/main">
               <a:ext uri="{FF2B5EF4-FFF2-40B4-BE49-F238E27FC236}">
-                <a16:creationId xmlns:a16="http://schemas.microsoft.com/office/drawing/2014/main" id="{8084A84F-0792-44B9-9BBF-2887DF22E183}"/>
+                <a16:creationId xmlns:a16="http://schemas.microsoft.com/office/drawing/2014/main" id="{37ADF154-CE68-4F05-AAFF-1A3B2EE64151}"/>
               </a:ext>
             </a:extLst>
           </p:cNvPr>
@@ -6973,7 +6973,7 @@
           <p:cNvPr id="2" name="">
             <a:extLst xmlns:a="http://schemas.openxmlformats.org/drawingml/2006/main">
               <a:ext uri="{FF2B5EF4-FFF2-40B4-BE49-F238E27FC236}">
-                <a16:creationId xmlns:a16="http://schemas.microsoft.com/office/drawing/2014/main" id="{16012AC1-FC96-48B6-A45B-B835C85A9FA0}"/>
+                <a16:creationId xmlns:a16="http://schemas.microsoft.com/office/drawing/2014/main" id="{32C6CC77-076A-43A4-BF0A-107F831ABC59}"/>
               </a:ext>
             </a:extLst>
           </p:cNvPr>
@@ -7030,7 +7030,7 @@
           <p:cNvPr id="3" name="">
             <a:extLst xmlns:a="http://schemas.openxmlformats.org/drawingml/2006/main">
               <a:ext uri="{FF2B5EF4-FFF2-40B4-BE49-F238E27FC236}">
-                <a16:creationId xmlns:a16="http://schemas.microsoft.com/office/drawing/2014/main" id="{1868333F-EED0-4C51-9778-8345A14975F0}"/>
+                <a16:creationId xmlns:a16="http://schemas.microsoft.com/office/drawing/2014/main" id="{801406A6-902A-41BF-81F9-3585B6923C9D}"/>
               </a:ext>
             </a:extLst>
           </p:cNvPr>
@@ -7112,7 +7112,7 @@
           <p:cNvPr id="4" name="">
             <a:extLst xmlns:a="http://schemas.openxmlformats.org/drawingml/2006/main">
               <a:ext uri="{FF2B5EF4-FFF2-40B4-BE49-F238E27FC236}">
-                <a16:creationId xmlns:a16="http://schemas.microsoft.com/office/drawing/2014/main" id="{1D849E14-C877-4B14-A5F0-E47D5A260206}"/>
+                <a16:creationId xmlns:a16="http://schemas.microsoft.com/office/drawing/2014/main" id="{8A766ACB-870A-458F-BBED-D72A66C673C1}"/>
               </a:ext>
             </a:extLst>
           </p:cNvPr>
@@ -7194,7 +7194,7 @@
           <p:cNvPr id="5" name="">
             <a:extLst xmlns:a="http://schemas.openxmlformats.org/drawingml/2006/main">
               <a:ext uri="{FF2B5EF4-FFF2-40B4-BE49-F238E27FC236}">
-                <a16:creationId xmlns:a16="http://schemas.microsoft.com/office/drawing/2014/main" id="{89C96DE7-AF2B-450D-85CE-B4C4B30CEB5E}"/>
+                <a16:creationId xmlns:a16="http://schemas.microsoft.com/office/drawing/2014/main" id="{39749D3B-3B41-4033-80B5-6DA49214C879}"/>
               </a:ext>
             </a:extLst>
           </p:cNvPr>
@@ -7276,7 +7276,7 @@
           <p:cNvPr id="6" name="">
             <a:extLst xmlns:a="http://schemas.openxmlformats.org/drawingml/2006/main">
               <a:ext uri="{FF2B5EF4-FFF2-40B4-BE49-F238E27FC236}">
-                <a16:creationId xmlns:a16="http://schemas.microsoft.com/office/drawing/2014/main" id="{F5E3E65B-7469-4D96-B1CA-D81D1DC1FF0F}"/>
+                <a16:creationId xmlns:a16="http://schemas.microsoft.com/office/drawing/2014/main" id="{15E514AC-1B98-46E5-8905-317538961338}"/>
               </a:ext>
             </a:extLst>
           </p:cNvPr>
@@ -7306,7 +7306,7 @@
           <p:cNvPr id="7" name="">
             <a:extLst xmlns:a="http://schemas.openxmlformats.org/drawingml/2006/main">
               <a:ext uri="{FF2B5EF4-FFF2-40B4-BE49-F238E27FC236}">
-                <a16:creationId xmlns:a16="http://schemas.microsoft.com/office/drawing/2014/main" id="{24F8AD82-40C8-4708-8E4C-3A0B92BF76E0}"/>
+                <a16:creationId xmlns:a16="http://schemas.microsoft.com/office/drawing/2014/main" id="{758C0D0B-B9A5-4374-B31E-8820996AAB78}"/>
               </a:ext>
             </a:extLst>
           </p:cNvPr>
@@ -7336,7 +7336,7 @@
           <p:cNvPr id="8" name="">
             <a:extLst xmlns:a="http://schemas.openxmlformats.org/drawingml/2006/main">
               <a:ext uri="{FF2B5EF4-FFF2-40B4-BE49-F238E27FC236}">
-                <a16:creationId xmlns:a16="http://schemas.microsoft.com/office/drawing/2014/main" id="{EFEF2AA4-81EE-43C3-B551-44B4F67914A6}"/>
+                <a16:creationId xmlns:a16="http://schemas.microsoft.com/office/drawing/2014/main" id="{C9E7720C-6620-4873-81FD-4EF7FA41B05D}"/>
               </a:ext>
             </a:extLst>
           </p:cNvPr>
@@ -7366,7 +7366,7 @@
           <p:cNvPr id="9" name="">
             <a:extLst xmlns:a="http://schemas.openxmlformats.org/drawingml/2006/main">
               <a:ext uri="{FF2B5EF4-FFF2-40B4-BE49-F238E27FC236}">
-                <a16:creationId xmlns:a16="http://schemas.microsoft.com/office/drawing/2014/main" id="{AAB1622E-1E2C-4D1A-A993-C1AE9F69339A}"/>
+                <a16:creationId xmlns:a16="http://schemas.microsoft.com/office/drawing/2014/main" id="{07FB4B77-BB4E-4EB6-8908-C5354AAB19AA}"/>
               </a:ext>
             </a:extLst>
           </p:cNvPr>
@@ -7425,7 +7425,7 @@
           <p:cNvPr id="10" name="">
             <a:extLst xmlns:a="http://schemas.openxmlformats.org/drawingml/2006/main">
               <a:ext uri="{FF2B5EF4-FFF2-40B4-BE49-F238E27FC236}">
-                <a16:creationId xmlns:a16="http://schemas.microsoft.com/office/drawing/2014/main" id="{22E48DEE-20E5-4D13-A54E-30B241D62347}"/>
+                <a16:creationId xmlns:a16="http://schemas.microsoft.com/office/drawing/2014/main" id="{F82A1AFE-B3B0-427A-B158-411340F6194B}"/>
               </a:ext>
             </a:extLst>
           </p:cNvPr>
@@ -7455,7 +7455,7 @@
           <p:cNvPr id="11" name="">
             <a:extLst xmlns:a="http://schemas.openxmlformats.org/drawingml/2006/main">
               <a:ext uri="{FF2B5EF4-FFF2-40B4-BE49-F238E27FC236}">
-                <a16:creationId xmlns:a16="http://schemas.microsoft.com/office/drawing/2014/main" id="{AC84E26E-2433-45FE-887E-A7A225EA23FE}"/>
+                <a16:creationId xmlns:a16="http://schemas.microsoft.com/office/drawing/2014/main" id="{A4D50086-354F-4538-A9AA-598736FF55FD}"/>
               </a:ext>
             </a:extLst>
           </p:cNvPr>
@@ -7514,7 +7514,7 @@
           <p:cNvPr id="12" name="">
             <a:extLst xmlns:a="http://schemas.openxmlformats.org/drawingml/2006/main">
               <a:ext uri="{FF2B5EF4-FFF2-40B4-BE49-F238E27FC236}">
-                <a16:creationId xmlns:a16="http://schemas.microsoft.com/office/drawing/2014/main" id="{345846FC-FD8F-49B0-80A5-637606B6FEC8}"/>
+                <a16:creationId xmlns:a16="http://schemas.microsoft.com/office/drawing/2014/main" id="{5D5B15DC-8616-4236-A0E1-23908E6F0A2B}"/>
               </a:ext>
             </a:extLst>
           </p:cNvPr>
@@ -7569,7 +7569,7 @@
     </p:spTree>
     <p:extLst>
       <p:ext uri="{BB962C8B-B14F-4D97-AF65-F5344CB8AC3E}">
-        <p14:creationId xmlns:p14="http://schemas.microsoft.com/office/powerpoint/2010/main" val="1133555174"/>
+        <p14:creationId xmlns:p14="http://schemas.microsoft.com/office/powerpoint/2010/main" val="1842418601"/>
       </p:ext>
     </p:extLst>
   </p:cSld>
@@ -7600,7 +7600,7 @@
           <p:cNvPr id="13" name="">
             <a:extLst xmlns:a="http://schemas.openxmlformats.org/drawingml/2006/main">
               <a:ext uri="{FF2B5EF4-FFF2-40B4-BE49-F238E27FC236}">
-                <a16:creationId xmlns:a16="http://schemas.microsoft.com/office/drawing/2014/main" id="{9F12C7F8-43C7-4DCF-AC6B-9E3818400544}"/>
+                <a16:creationId xmlns:a16="http://schemas.microsoft.com/office/drawing/2014/main" id="{2B47F3AE-2E1D-444A-A29A-138349ABC66A}"/>
               </a:ext>
             </a:extLst>
           </p:cNvPr>
@@ -7657,7 +7657,7 @@
           <p:cNvPr id="2" name="">
             <a:extLst xmlns:a="http://schemas.openxmlformats.org/drawingml/2006/main">
               <a:ext uri="{FF2B5EF4-FFF2-40B4-BE49-F238E27FC236}">
-                <a16:creationId xmlns:a16="http://schemas.microsoft.com/office/drawing/2014/main" id="{3217B1E5-C974-439B-9AC1-5E339CEE05A1}"/>
+                <a16:creationId xmlns:a16="http://schemas.microsoft.com/office/drawing/2014/main" id="{77B5B740-4267-411D-A2BD-723EF33E023D}"/>
               </a:ext>
             </a:extLst>
           </p:cNvPr>
@@ -7714,7 +7714,7 @@
           <p:cNvPr id="3" name="">
             <a:extLst xmlns:a="http://schemas.openxmlformats.org/drawingml/2006/main">
               <a:ext uri="{FF2B5EF4-FFF2-40B4-BE49-F238E27FC236}">
-                <a16:creationId xmlns:a16="http://schemas.microsoft.com/office/drawing/2014/main" id="{E87B71E6-DABB-43B5-98A3-A53D055EE4E7}"/>
+                <a16:creationId xmlns:a16="http://schemas.microsoft.com/office/drawing/2014/main" id="{EA171357-B93A-47ED-841B-106F4A41B3CB}"/>
               </a:ext>
             </a:extLst>
           </p:cNvPr>
@@ -7796,7 +7796,7 @@
           <p:cNvPr id="4" name="">
             <a:extLst xmlns:a="http://schemas.openxmlformats.org/drawingml/2006/main">
               <a:ext uri="{FF2B5EF4-FFF2-40B4-BE49-F238E27FC236}">
-                <a16:creationId xmlns:a16="http://schemas.microsoft.com/office/drawing/2014/main" id="{F37B0114-F6A6-4F08-8937-F709D8577536}"/>
+                <a16:creationId xmlns:a16="http://schemas.microsoft.com/office/drawing/2014/main" id="{FC962E9B-4C9F-4F01-8548-9413360B27EB}"/>
               </a:ext>
             </a:extLst>
           </p:cNvPr>
@@ -7826,7 +7826,7 @@
           <p:cNvPr id="5" name="">
             <a:extLst xmlns:a="http://schemas.openxmlformats.org/drawingml/2006/main">
               <a:ext uri="{FF2B5EF4-FFF2-40B4-BE49-F238E27FC236}">
-                <a16:creationId xmlns:a16="http://schemas.microsoft.com/office/drawing/2014/main" id="{765FA9C3-45E3-4A7B-9E0C-26263F885287}"/>
+                <a16:creationId xmlns:a16="http://schemas.microsoft.com/office/drawing/2014/main" id="{4B98B319-64FB-4C0A-B0FE-95C3B48FD504}"/>
               </a:ext>
             </a:extLst>
           </p:cNvPr>
@@ -7908,7 +7908,7 @@
           <p:cNvPr id="6" name="">
             <a:extLst xmlns:a="http://schemas.openxmlformats.org/drawingml/2006/main">
               <a:ext uri="{FF2B5EF4-FFF2-40B4-BE49-F238E27FC236}">
-                <a16:creationId xmlns:a16="http://schemas.microsoft.com/office/drawing/2014/main" id="{894747A2-E5AC-4208-A9BF-44CFEF3621D7}"/>
+                <a16:creationId xmlns:a16="http://schemas.microsoft.com/office/drawing/2014/main" id="{2A90C756-D986-4C1E-B0AD-72ED99C96A2F}"/>
               </a:ext>
             </a:extLst>
           </p:cNvPr>
@@ -7938,7 +7938,7 @@
           <p:cNvPr id="7" name="">
             <a:extLst xmlns:a="http://schemas.openxmlformats.org/drawingml/2006/main">
               <a:ext uri="{FF2B5EF4-FFF2-40B4-BE49-F238E27FC236}">
-                <a16:creationId xmlns:a16="http://schemas.microsoft.com/office/drawing/2014/main" id="{113C2B7B-4F6B-4556-ABF8-E05CF2652D7A}"/>
+                <a16:creationId xmlns:a16="http://schemas.microsoft.com/office/drawing/2014/main" id="{A2425EA1-8A0E-4E14-9610-8AFB1ADE1CE7}"/>
               </a:ext>
             </a:extLst>
           </p:cNvPr>
@@ -8020,7 +8020,7 @@
           <p:cNvPr id="8" name="">
             <a:extLst xmlns:a="http://schemas.openxmlformats.org/drawingml/2006/main">
               <a:ext uri="{FF2B5EF4-FFF2-40B4-BE49-F238E27FC236}">
-                <a16:creationId xmlns:a16="http://schemas.microsoft.com/office/drawing/2014/main" id="{A09A8D9A-2C43-4B72-96FE-619B90247621}"/>
+                <a16:creationId xmlns:a16="http://schemas.microsoft.com/office/drawing/2014/main" id="{74648190-9923-4C9F-B2C8-E2493C122168}"/>
               </a:ext>
             </a:extLst>
           </p:cNvPr>
@@ -8050,7 +8050,7 @@
           <p:cNvPr id="9" name="">
             <a:extLst xmlns:a="http://schemas.openxmlformats.org/drawingml/2006/main">
               <a:ext uri="{FF2B5EF4-FFF2-40B4-BE49-F238E27FC236}">
-                <a16:creationId xmlns:a16="http://schemas.microsoft.com/office/drawing/2014/main" id="{DDC66083-48E6-40BB-9E1F-C012EEC69738}"/>
+                <a16:creationId xmlns:a16="http://schemas.microsoft.com/office/drawing/2014/main" id="{FA9A0E97-EDCC-4C2E-BF05-221F45309F0E}"/>
               </a:ext>
             </a:extLst>
           </p:cNvPr>
@@ -8132,7 +8132,7 @@
           <p:cNvPr id="10" name="">
             <a:extLst xmlns:a="http://schemas.openxmlformats.org/drawingml/2006/main">
               <a:ext uri="{FF2B5EF4-FFF2-40B4-BE49-F238E27FC236}">
-                <a16:creationId xmlns:a16="http://schemas.microsoft.com/office/drawing/2014/main" id="{5472F88E-F545-4BD8-AAAD-26E1FA2393EA}"/>
+                <a16:creationId xmlns:a16="http://schemas.microsoft.com/office/drawing/2014/main" id="{17215E02-B4B3-4708-8C55-3C447FA600F8}"/>
               </a:ext>
             </a:extLst>
           </p:cNvPr>
@@ -8189,7 +8189,7 @@
           <p:cNvPr id="11" name="">
             <a:extLst xmlns:a="http://schemas.openxmlformats.org/drawingml/2006/main">
               <a:ext uri="{FF2B5EF4-FFF2-40B4-BE49-F238E27FC236}">
-                <a16:creationId xmlns:a16="http://schemas.microsoft.com/office/drawing/2014/main" id="{2EC7D1AE-8458-40A4-A140-DEE73F4C0855}"/>
+                <a16:creationId xmlns:a16="http://schemas.microsoft.com/office/drawing/2014/main" id="{3493FAD7-9800-4DE6-9B64-88DF34477DDC}"/>
               </a:ext>
             </a:extLst>
           </p:cNvPr>
@@ -8246,7 +8246,7 @@
           <p:cNvPr id="12" name="">
             <a:extLst xmlns:a="http://schemas.openxmlformats.org/drawingml/2006/main">
               <a:ext uri="{FF2B5EF4-FFF2-40B4-BE49-F238E27FC236}">
-                <a16:creationId xmlns:a16="http://schemas.microsoft.com/office/drawing/2014/main" id="{E253724C-6A2F-4038-BBE1-DEA34999D482}"/>
+                <a16:creationId xmlns:a16="http://schemas.microsoft.com/office/drawing/2014/main" id="{134970C8-A67D-47FF-8C3E-E0B50C75FC16}"/>
               </a:ext>
             </a:extLst>
           </p:cNvPr>
@@ -8301,7 +8301,7 @@
     </p:spTree>
     <p:extLst>
       <p:ext uri="{BB962C8B-B14F-4D97-AF65-F5344CB8AC3E}">
-        <p14:creationId xmlns:p14="http://schemas.microsoft.com/office/powerpoint/2010/main" val="2054261624"/>
+        <p14:creationId xmlns:p14="http://schemas.microsoft.com/office/powerpoint/2010/main" val="1121209416"/>
       </p:ext>
     </p:extLst>
   </p:cSld>
@@ -8332,7 +8332,7 @@
           <p:cNvPr id="10" name="">
             <a:extLst xmlns:a="http://schemas.openxmlformats.org/drawingml/2006/main">
               <a:ext uri="{FF2B5EF4-FFF2-40B4-BE49-F238E27FC236}">
-                <a16:creationId xmlns:a16="http://schemas.microsoft.com/office/drawing/2014/main" id="{FF66BDFD-0561-4A11-84CF-978222851FD9}"/>
+                <a16:creationId xmlns:a16="http://schemas.microsoft.com/office/drawing/2014/main" id="{2211DAFF-1EFF-4B29-9360-12A1ECC8341C}"/>
               </a:ext>
             </a:extLst>
           </p:cNvPr>
@@ -8389,7 +8389,7 @@
           <p:cNvPr id="2" name="">
             <a:extLst xmlns:a="http://schemas.openxmlformats.org/drawingml/2006/main">
               <a:ext uri="{FF2B5EF4-FFF2-40B4-BE49-F238E27FC236}">
-                <a16:creationId xmlns:a16="http://schemas.microsoft.com/office/drawing/2014/main" id="{4F00AA6B-4736-4371-9956-9AE06477A3A9}"/>
+                <a16:creationId xmlns:a16="http://schemas.microsoft.com/office/drawing/2014/main" id="{85ABFDB9-EFD4-4E42-A30E-BAD9A7F1A103}"/>
               </a:ext>
             </a:extLst>
           </p:cNvPr>
@@ -8446,7 +8446,7 @@
           <p:cNvPr id="3" name="">
             <a:extLst xmlns:a="http://schemas.openxmlformats.org/drawingml/2006/main">
               <a:ext uri="{FF2B5EF4-FFF2-40B4-BE49-F238E27FC236}">
-                <a16:creationId xmlns:a16="http://schemas.microsoft.com/office/drawing/2014/main" id="{E39A27DD-BC0D-44F0-9AA9-5CA6D7006A21}"/>
+                <a16:creationId xmlns:a16="http://schemas.microsoft.com/office/drawing/2014/main" id="{A63ECA8D-6A1F-4276-84CD-C8DB58088EF0}"/>
               </a:ext>
             </a:extLst>
           </p:cNvPr>
@@ -8503,7 +8503,7 @@
           <p:cNvPr id="4" name="">
             <a:extLst xmlns:a="http://schemas.openxmlformats.org/drawingml/2006/main">
               <a:ext uri="{FF2B5EF4-FFF2-40B4-BE49-F238E27FC236}">
-                <a16:creationId xmlns:a16="http://schemas.microsoft.com/office/drawing/2014/main" id="{6D63B68F-CBC7-438B-969D-385C76B7A542}"/>
+                <a16:creationId xmlns:a16="http://schemas.microsoft.com/office/drawing/2014/main" id="{5A672CE6-1073-4E53-BBD5-C4435020DA29}"/>
               </a:ext>
             </a:extLst>
           </p:cNvPr>
@@ -8560,7 +8560,7 @@
           <p:cNvPr id="5" name="">
             <a:extLst xmlns:a="http://schemas.openxmlformats.org/drawingml/2006/main">
               <a:ext uri="{FF2B5EF4-FFF2-40B4-BE49-F238E27FC236}">
-                <a16:creationId xmlns:a16="http://schemas.microsoft.com/office/drawing/2014/main" id="{8C276699-7A53-4A0C-B328-3A8083007DBC}"/>
+                <a16:creationId xmlns:a16="http://schemas.microsoft.com/office/drawing/2014/main" id="{F6E33010-B3F7-49EF-9999-ABE133507145}"/>
               </a:ext>
             </a:extLst>
           </p:cNvPr>
@@ -8617,7 +8617,7 @@
           <p:cNvPr id="6" name="">
             <a:extLst xmlns:a="http://schemas.openxmlformats.org/drawingml/2006/main">
               <a:ext uri="{FF2B5EF4-FFF2-40B4-BE49-F238E27FC236}">
-                <a16:creationId xmlns:a16="http://schemas.microsoft.com/office/drawing/2014/main" id="{B0E53FC4-7B8A-4085-A50C-A864B80CF49F}"/>
+                <a16:creationId xmlns:a16="http://schemas.microsoft.com/office/drawing/2014/main" id="{338CABC2-8860-4DEE-B7DB-3EBF83D086CC}"/>
               </a:ext>
             </a:extLst>
           </p:cNvPr>
@@ -8674,7 +8674,7 @@
           <p:cNvPr id="7" name="">
             <a:extLst xmlns:a="http://schemas.openxmlformats.org/drawingml/2006/main">
               <a:ext uri="{FF2B5EF4-FFF2-40B4-BE49-F238E27FC236}">
-                <a16:creationId xmlns:a16="http://schemas.microsoft.com/office/drawing/2014/main" id="{7747C8FC-09C4-47E1-AE2B-E0E953C5C378}"/>
+                <a16:creationId xmlns:a16="http://schemas.microsoft.com/office/drawing/2014/main" id="{C38A964E-3B6B-428B-B073-981953447AFB}"/>
               </a:ext>
             </a:extLst>
           </p:cNvPr>
@@ -8731,7 +8731,7 @@
           <p:cNvPr id="8" name="">
             <a:extLst xmlns:a="http://schemas.openxmlformats.org/drawingml/2006/main">
               <a:ext uri="{FF2B5EF4-FFF2-40B4-BE49-F238E27FC236}">
-                <a16:creationId xmlns:a16="http://schemas.microsoft.com/office/drawing/2014/main" id="{232D61AF-9547-45D4-8EEC-C5743BB3C681}"/>
+                <a16:creationId xmlns:a16="http://schemas.microsoft.com/office/drawing/2014/main" id="{E9B6D9DA-0C0E-4C86-8B7A-9394723C34D5}"/>
               </a:ext>
             </a:extLst>
           </p:cNvPr>
@@ -8788,7 +8788,7 @@
           <p:cNvPr id="9" name="">
             <a:extLst xmlns:a="http://schemas.openxmlformats.org/drawingml/2006/main">
               <a:ext uri="{FF2B5EF4-FFF2-40B4-BE49-F238E27FC236}">
-                <a16:creationId xmlns:a16="http://schemas.microsoft.com/office/drawing/2014/main" id="{741A9402-12B6-4DCF-A895-B7183EDA7B29}"/>
+                <a16:creationId xmlns:a16="http://schemas.microsoft.com/office/drawing/2014/main" id="{85F00009-E659-4542-B3D8-BF1973E9263E}"/>
               </a:ext>
             </a:extLst>
           </p:cNvPr>
@@ -8843,7 +8843,7 @@
     </p:spTree>
     <p:extLst>
       <p:ext uri="{BB962C8B-B14F-4D97-AF65-F5344CB8AC3E}">
-        <p14:creationId xmlns:p14="http://schemas.microsoft.com/office/powerpoint/2010/main" val="296239952"/>
+        <p14:creationId xmlns:p14="http://schemas.microsoft.com/office/powerpoint/2010/main" val="2040537260"/>
       </p:ext>
     </p:extLst>
   </p:cSld>
@@ -8874,7 +8874,7 @@
           <p:cNvPr id="10" name="">
             <a:extLst xmlns:a="http://schemas.openxmlformats.org/drawingml/2006/main">
               <a:ext uri="{FF2B5EF4-FFF2-40B4-BE49-F238E27FC236}">
-                <a16:creationId xmlns:a16="http://schemas.microsoft.com/office/drawing/2014/main" id="{D53092A6-AD20-45B3-8512-B1619EE3E077}"/>
+                <a16:creationId xmlns:a16="http://schemas.microsoft.com/office/drawing/2014/main" id="{019FF199-6ADD-43D2-B3F6-D0871A43DC6F}"/>
               </a:ext>
             </a:extLst>
           </p:cNvPr>
@@ -8931,7 +8931,7 @@
           <p:cNvPr id="2" name="">
             <a:extLst xmlns:a="http://schemas.openxmlformats.org/drawingml/2006/main">
               <a:ext uri="{FF2B5EF4-FFF2-40B4-BE49-F238E27FC236}">
-                <a16:creationId xmlns:a16="http://schemas.microsoft.com/office/drawing/2014/main" id="{CB789B08-0A2F-47CE-B373-86A282F46BFE}"/>
+                <a16:creationId xmlns:a16="http://schemas.microsoft.com/office/drawing/2014/main" id="{65B62BE5-08B4-46C4-BB87-E10884BA70DE}"/>
               </a:ext>
             </a:extLst>
           </p:cNvPr>
@@ -8988,7 +8988,7 @@
           <p:cNvPr id="3" name="">
             <a:extLst xmlns:a="http://schemas.openxmlformats.org/drawingml/2006/main">
               <a:ext uri="{FF2B5EF4-FFF2-40B4-BE49-F238E27FC236}">
-                <a16:creationId xmlns:a16="http://schemas.microsoft.com/office/drawing/2014/main" id="{AFCABE88-30C1-414E-B5E6-6A1C9AF03489}"/>
+                <a16:creationId xmlns:a16="http://schemas.microsoft.com/office/drawing/2014/main" id="{3CEFB67F-C8B4-4F66-A8BC-7A23A8256279}"/>
               </a:ext>
             </a:extLst>
           </p:cNvPr>
@@ -9045,7 +9045,7 @@
           <p:cNvPr id="4" name="">
             <a:extLst xmlns:a="http://schemas.openxmlformats.org/drawingml/2006/main">
               <a:ext uri="{FF2B5EF4-FFF2-40B4-BE49-F238E27FC236}">
-                <a16:creationId xmlns:a16="http://schemas.microsoft.com/office/drawing/2014/main" id="{4A1ECA75-0880-45EA-BCC5-A6FE080CBAD0}"/>
+                <a16:creationId xmlns:a16="http://schemas.microsoft.com/office/drawing/2014/main" id="{59FCA888-66EE-4572-9175-62554C764FE0}"/>
               </a:ext>
             </a:extLst>
           </p:cNvPr>
@@ -9102,7 +9102,7 @@
           <p:cNvPr id="5" name="">
             <a:extLst xmlns:a="http://schemas.openxmlformats.org/drawingml/2006/main">
               <a:ext uri="{FF2B5EF4-FFF2-40B4-BE49-F238E27FC236}">
-                <a16:creationId xmlns:a16="http://schemas.microsoft.com/office/drawing/2014/main" id="{0FB2ECD8-F0E7-4206-BE02-0851F754C446}"/>
+                <a16:creationId xmlns:a16="http://schemas.microsoft.com/office/drawing/2014/main" id="{23F1FE34-3CBF-414F-942C-7647D2C86AA4}"/>
               </a:ext>
             </a:extLst>
           </p:cNvPr>
@@ -9159,7 +9159,7 @@
           <p:cNvPr id="6" name="">
             <a:extLst xmlns:a="http://schemas.openxmlformats.org/drawingml/2006/main">
               <a:ext uri="{FF2B5EF4-FFF2-40B4-BE49-F238E27FC236}">
-                <a16:creationId xmlns:a16="http://schemas.microsoft.com/office/drawing/2014/main" id="{C6D7A978-CA87-4C8C-85E0-9BC698D1402E}"/>
+                <a16:creationId xmlns:a16="http://schemas.microsoft.com/office/drawing/2014/main" id="{F6555BDB-E7D9-4DD8-9D2B-EBEDBE25EAF4}"/>
               </a:ext>
             </a:extLst>
           </p:cNvPr>
@@ -9216,7 +9216,7 @@
           <p:cNvPr id="7" name="">
             <a:extLst xmlns:a="http://schemas.openxmlformats.org/drawingml/2006/main">
               <a:ext uri="{FF2B5EF4-FFF2-40B4-BE49-F238E27FC236}">
-                <a16:creationId xmlns:a16="http://schemas.microsoft.com/office/drawing/2014/main" id="{5F5C0D5E-8E23-4BC2-984F-A13537458962}"/>
+                <a16:creationId xmlns:a16="http://schemas.microsoft.com/office/drawing/2014/main" id="{CF38488C-3802-435C-832E-0E01863EF39E}"/>
               </a:ext>
             </a:extLst>
           </p:cNvPr>
@@ -9273,7 +9273,7 @@
           <p:cNvPr id="8" name="">
             <a:extLst xmlns:a="http://schemas.openxmlformats.org/drawingml/2006/main">
               <a:ext uri="{FF2B5EF4-FFF2-40B4-BE49-F238E27FC236}">
-                <a16:creationId xmlns:a16="http://schemas.microsoft.com/office/drawing/2014/main" id="{69061FC5-9F7A-4CDF-AC98-ED7EC1A6A7F6}"/>
+                <a16:creationId xmlns:a16="http://schemas.microsoft.com/office/drawing/2014/main" id="{ACA366BA-454C-4973-88A2-4C6D8A84F93B}"/>
               </a:ext>
             </a:extLst>
           </p:cNvPr>
@@ -9330,7 +9330,7 @@
           <p:cNvPr id="9" name="">
             <a:extLst xmlns:a="http://schemas.openxmlformats.org/drawingml/2006/main">
               <a:ext uri="{FF2B5EF4-FFF2-40B4-BE49-F238E27FC236}">
-                <a16:creationId xmlns:a16="http://schemas.microsoft.com/office/drawing/2014/main" id="{46CAAA49-6E65-484B-9BC4-97EE8DB8D02B}"/>
+                <a16:creationId xmlns:a16="http://schemas.microsoft.com/office/drawing/2014/main" id="{D0EF5405-2288-4116-AE97-09B541A7D02E}"/>
               </a:ext>
             </a:extLst>
           </p:cNvPr>
@@ -9385,7 +9385,7 @@
     </p:spTree>
     <p:extLst>
       <p:ext uri="{BB962C8B-B14F-4D97-AF65-F5344CB8AC3E}">
-        <p14:creationId xmlns:p14="http://schemas.microsoft.com/office/powerpoint/2010/main" val="838041523"/>
+        <p14:creationId xmlns:p14="http://schemas.microsoft.com/office/powerpoint/2010/main" val="737478432"/>
       </p:ext>
     </p:extLst>
   </p:cSld>
@@ -9416,7 +9416,7 @@
           <p:cNvPr id="5" name="">
             <a:extLst xmlns:a="http://schemas.openxmlformats.org/drawingml/2006/main">
               <a:ext uri="{FF2B5EF4-FFF2-40B4-BE49-F238E27FC236}">
-                <a16:creationId xmlns:a16="http://schemas.microsoft.com/office/drawing/2014/main" id="{A2904FE1-8B1A-4681-81BC-1A563699DDBC}"/>
+                <a16:creationId xmlns:a16="http://schemas.microsoft.com/office/drawing/2014/main" id="{BEFD7DE4-2174-44A7-AF51-BE3A9465D8F1}"/>
               </a:ext>
             </a:extLst>
           </p:cNvPr>
@@ -9473,7 +9473,7 @@
           <p:cNvPr id="2" name="">
             <a:extLst xmlns:a="http://schemas.openxmlformats.org/drawingml/2006/main">
               <a:ext uri="{FF2B5EF4-FFF2-40B4-BE49-F238E27FC236}">
-                <a16:creationId xmlns:a16="http://schemas.microsoft.com/office/drawing/2014/main" id="{0BAA0F0F-5859-4741-BC37-D1B58AAAE2B3}"/>
+                <a16:creationId xmlns:a16="http://schemas.microsoft.com/office/drawing/2014/main" id="{B47603D5-04CB-4451-B925-C6C671C293DD}"/>
               </a:ext>
             </a:extLst>
           </p:cNvPr>
@@ -9997,7 +9997,7 @@
           <p:cNvPr id="4" name="">
             <a:extLst xmlns:a="http://schemas.openxmlformats.org/drawingml/2006/main">
               <a:ext uri="{FF2B5EF4-FFF2-40B4-BE49-F238E27FC236}">
-                <a16:creationId xmlns:a16="http://schemas.microsoft.com/office/drawing/2014/main" id="{7A66F5D1-1CD7-4B15-BB5D-22A59E765F8E}"/>
+                <a16:creationId xmlns:a16="http://schemas.microsoft.com/office/drawing/2014/main" id="{67E73278-7A4A-43CE-9152-0E86F01D598B}"/>
               </a:ext>
             </a:extLst>
           </p:cNvPr>
@@ -10052,7 +10052,7 @@
     </p:spTree>
     <p:extLst>
       <p:ext uri="{BB962C8B-B14F-4D97-AF65-F5344CB8AC3E}">
-        <p14:creationId xmlns:p14="http://schemas.microsoft.com/office/powerpoint/2010/main" val="908953900"/>
+        <p14:creationId xmlns:p14="http://schemas.microsoft.com/office/powerpoint/2010/main" val="787823608"/>
       </p:ext>
     </p:extLst>
   </p:cSld>
@@ -10083,7 +10083,7 @@
           <p:cNvPr id="10" name="">
             <a:extLst xmlns:a="http://schemas.openxmlformats.org/drawingml/2006/main">
               <a:ext uri="{FF2B5EF4-FFF2-40B4-BE49-F238E27FC236}">
-                <a16:creationId xmlns:a16="http://schemas.microsoft.com/office/drawing/2014/main" id="{CB721724-C2F0-415C-AF2D-84DA81E6FCFB}"/>
+                <a16:creationId xmlns:a16="http://schemas.microsoft.com/office/drawing/2014/main" id="{B4EB7F82-5B39-49FD-96F1-09E4725A6D8C}"/>
               </a:ext>
             </a:extLst>
           </p:cNvPr>
@@ -10140,7 +10140,7 @@
           <p:cNvPr id="2" name="">
             <a:extLst xmlns:a="http://schemas.openxmlformats.org/drawingml/2006/main">
               <a:ext uri="{FF2B5EF4-FFF2-40B4-BE49-F238E27FC236}">
-                <a16:creationId xmlns:a16="http://schemas.microsoft.com/office/drawing/2014/main" id="{A313AF6F-C0C5-4CE8-A1A5-6B234D4252B7}"/>
+                <a16:creationId xmlns:a16="http://schemas.microsoft.com/office/drawing/2014/main" id="{800E8D62-A346-4A52-AB22-096D83473E8F}"/>
               </a:ext>
             </a:extLst>
           </p:cNvPr>
@@ -10197,7 +10197,7 @@
           <p:cNvPr id="3" name="">
             <a:extLst xmlns:a="http://schemas.openxmlformats.org/drawingml/2006/main">
               <a:ext uri="{FF2B5EF4-FFF2-40B4-BE49-F238E27FC236}">
-                <a16:creationId xmlns:a16="http://schemas.microsoft.com/office/drawing/2014/main" id="{9FFD5A4F-5125-4A6E-859C-7A8485CF614E}"/>
+                <a16:creationId xmlns:a16="http://schemas.microsoft.com/office/drawing/2014/main" id="{3B021839-A493-4A48-803C-D04B831D5878}"/>
               </a:ext>
             </a:extLst>
           </p:cNvPr>
@@ -10254,7 +10254,7 @@
           <p:cNvPr id="4" name="">
             <a:extLst xmlns:a="http://schemas.openxmlformats.org/drawingml/2006/main">
               <a:ext uri="{FF2B5EF4-FFF2-40B4-BE49-F238E27FC236}">
-                <a16:creationId xmlns:a16="http://schemas.microsoft.com/office/drawing/2014/main" id="{1BAEC68C-A0AE-4B9C-956B-487CB29FA579}"/>
+                <a16:creationId xmlns:a16="http://schemas.microsoft.com/office/drawing/2014/main" id="{F80B2310-42CD-4DFA-9F21-33E8EDFB284F}"/>
               </a:ext>
             </a:extLst>
           </p:cNvPr>
@@ -10311,7 +10311,7 @@
           <p:cNvPr id="5" name="">
             <a:extLst xmlns:a="http://schemas.openxmlformats.org/drawingml/2006/main">
               <a:ext uri="{FF2B5EF4-FFF2-40B4-BE49-F238E27FC236}">
-                <a16:creationId xmlns:a16="http://schemas.microsoft.com/office/drawing/2014/main" id="{F299AA91-09EE-41B0-944D-328D3CAFAE51}"/>
+                <a16:creationId xmlns:a16="http://schemas.microsoft.com/office/drawing/2014/main" id="{8BF5D3F1-5458-46AF-8EB9-56922BF7F112}"/>
               </a:ext>
             </a:extLst>
           </p:cNvPr>
@@ -10368,7 +10368,7 @@
           <p:cNvPr id="6" name="">
             <a:extLst xmlns:a="http://schemas.openxmlformats.org/drawingml/2006/main">
               <a:ext uri="{FF2B5EF4-FFF2-40B4-BE49-F238E27FC236}">
-                <a16:creationId xmlns:a16="http://schemas.microsoft.com/office/drawing/2014/main" id="{9B83E838-FDBD-4A23-90D0-58D8E2DACF17}"/>
+                <a16:creationId xmlns:a16="http://schemas.microsoft.com/office/drawing/2014/main" id="{C40D4841-01DD-4567-AF2B-02A16F5D3445}"/>
               </a:ext>
             </a:extLst>
           </p:cNvPr>
@@ -10425,7 +10425,7 @@
           <p:cNvPr id="7" name="">
             <a:extLst xmlns:a="http://schemas.openxmlformats.org/drawingml/2006/main">
               <a:ext uri="{FF2B5EF4-FFF2-40B4-BE49-F238E27FC236}">
-                <a16:creationId xmlns:a16="http://schemas.microsoft.com/office/drawing/2014/main" id="{D7FADCD5-85D2-4A74-9369-3FE8E2436D3C}"/>
+                <a16:creationId xmlns:a16="http://schemas.microsoft.com/office/drawing/2014/main" id="{5EC36800-B92E-46ED-BA72-267E3CE47D59}"/>
               </a:ext>
             </a:extLst>
           </p:cNvPr>
@@ -10482,7 +10482,7 @@
           <p:cNvPr id="8" name="">
             <a:extLst xmlns:a="http://schemas.openxmlformats.org/drawingml/2006/main">
               <a:ext uri="{FF2B5EF4-FFF2-40B4-BE49-F238E27FC236}">
-                <a16:creationId xmlns:a16="http://schemas.microsoft.com/office/drawing/2014/main" id="{0FC38AFB-CA67-49AD-A4CF-B59BD4A53CF3}"/>
+                <a16:creationId xmlns:a16="http://schemas.microsoft.com/office/drawing/2014/main" id="{DAD126F3-8197-416D-B346-1A8264B6B053}"/>
               </a:ext>
             </a:extLst>
           </p:cNvPr>
@@ -10539,7 +10539,7 @@
           <p:cNvPr id="9" name="">
             <a:extLst xmlns:a="http://schemas.openxmlformats.org/drawingml/2006/main">
               <a:ext uri="{FF2B5EF4-FFF2-40B4-BE49-F238E27FC236}">
-                <a16:creationId xmlns:a16="http://schemas.microsoft.com/office/drawing/2014/main" id="{9773D3BC-9586-4560-88D3-195A47C8CE88}"/>
+                <a16:creationId xmlns:a16="http://schemas.microsoft.com/office/drawing/2014/main" id="{64C60C79-19F7-4F23-9757-A75553FB7470}"/>
               </a:ext>
             </a:extLst>
           </p:cNvPr>
@@ -10594,7 +10594,7 @@
     </p:spTree>
     <p:extLst>
       <p:ext uri="{BB962C8B-B14F-4D97-AF65-F5344CB8AC3E}">
-        <p14:creationId xmlns:p14="http://schemas.microsoft.com/office/powerpoint/2010/main" val="790764881"/>
+        <p14:creationId xmlns:p14="http://schemas.microsoft.com/office/powerpoint/2010/main" val="1970671328"/>
       </p:ext>
     </p:extLst>
   </p:cSld>

</xml_diff>

<commit_message>
docs(portfolio): 현재 Claude 다섯 업무 인수 증거 반영
</commit_message>
<xml_diff>
--- a/docs/portfolio/mulino-coreano-portfolio-ko.pptx
+++ b/docs/portfolio/mulino-coreano-portfolio-ko.pptx
@@ -2,26 +2,26 @@
 <file path=ppt/presentation.xml><?xml version="1.0" encoding="utf-8"?>
 <p:presentation xmlns:p="http://schemas.openxmlformats.org/presentationml/2006/main">
   <p:sldMasterIdLst>
-    <p:sldMasterId xmlns:r="http://schemas.openxmlformats.org/officeDocument/2006/relationships" id="2147483648" r:id="Rc4e72562fe714267"/>
+    <p:sldMasterId xmlns:r="http://schemas.openxmlformats.org/officeDocument/2006/relationships" id="2147483648" r:id="Rbb5c2e04d0be4074"/>
   </p:sldMasterIdLst>
   <p:notesMasterIdLst>
-    <p:notesMasterId xmlns:r="http://schemas.openxmlformats.org/officeDocument/2006/relationships" r:id="R080206761b9e46ab"/>
+    <p:notesMasterId xmlns:r="http://schemas.openxmlformats.org/officeDocument/2006/relationships" r:id="R46987cd57512430c"/>
   </p:notesMasterIdLst>
   <p:sldIdLst>
-    <p:sldId xmlns:r="http://schemas.openxmlformats.org/officeDocument/2006/relationships" id="256" r:id="R709f6f8349c14a5d"/>
-    <p:sldId xmlns:r="http://schemas.openxmlformats.org/officeDocument/2006/relationships" id="257" r:id="Re60a37df260c4bad"/>
-    <p:sldId xmlns:r="http://schemas.openxmlformats.org/officeDocument/2006/relationships" id="258" r:id="R544575ac39a14c4f"/>
-    <p:sldId xmlns:r="http://schemas.openxmlformats.org/officeDocument/2006/relationships" id="259" r:id="R3d172498382e4c0b"/>
-    <p:sldId xmlns:r="http://schemas.openxmlformats.org/officeDocument/2006/relationships" id="260" r:id="R85209cfb29b4465c"/>
-    <p:sldId xmlns:r="http://schemas.openxmlformats.org/officeDocument/2006/relationships" id="261" r:id="Ra796101282614e73"/>
-    <p:sldId xmlns:r="http://schemas.openxmlformats.org/officeDocument/2006/relationships" id="262" r:id="R1b87077046a744de"/>
-    <p:sldId xmlns:r="http://schemas.openxmlformats.org/officeDocument/2006/relationships" id="263" r:id="R4bfa96d9efd9403f"/>
-    <p:sldId xmlns:r="http://schemas.openxmlformats.org/officeDocument/2006/relationships" id="264" r:id="R8fa565a17ead498f"/>
-    <p:sldId xmlns:r="http://schemas.openxmlformats.org/officeDocument/2006/relationships" id="265" r:id="R728e87b5c7ae4d5e"/>
-    <p:sldId xmlns:r="http://schemas.openxmlformats.org/officeDocument/2006/relationships" id="266" r:id="R29c3cb1e3f184fc7"/>
-    <p:sldId xmlns:r="http://schemas.openxmlformats.org/officeDocument/2006/relationships" id="267" r:id="R0768cee37bd644e9"/>
-    <p:sldId xmlns:r="http://schemas.openxmlformats.org/officeDocument/2006/relationships" id="268" r:id="R29e82e267dbd4b5a"/>
-    <p:sldId xmlns:r="http://schemas.openxmlformats.org/officeDocument/2006/relationships" id="269" r:id="R19769d0d66234a4d"/>
+    <p:sldId xmlns:r="http://schemas.openxmlformats.org/officeDocument/2006/relationships" id="256" r:id="Rde235967f63c46b5"/>
+    <p:sldId xmlns:r="http://schemas.openxmlformats.org/officeDocument/2006/relationships" id="257" r:id="R3899dbbe64d24160"/>
+    <p:sldId xmlns:r="http://schemas.openxmlformats.org/officeDocument/2006/relationships" id="258" r:id="R90ecfbe49f954968"/>
+    <p:sldId xmlns:r="http://schemas.openxmlformats.org/officeDocument/2006/relationships" id="259" r:id="Rf33ce9532e134a38"/>
+    <p:sldId xmlns:r="http://schemas.openxmlformats.org/officeDocument/2006/relationships" id="260" r:id="R8d4c813e871c4f1b"/>
+    <p:sldId xmlns:r="http://schemas.openxmlformats.org/officeDocument/2006/relationships" id="261" r:id="Rf4cc0d84829c4cf8"/>
+    <p:sldId xmlns:r="http://schemas.openxmlformats.org/officeDocument/2006/relationships" id="262" r:id="Rfa34737afae04bfb"/>
+    <p:sldId xmlns:r="http://schemas.openxmlformats.org/officeDocument/2006/relationships" id="263" r:id="Rbe617ef43ce94d08"/>
+    <p:sldId xmlns:r="http://schemas.openxmlformats.org/officeDocument/2006/relationships" id="264" r:id="R22243b5cff2d4f16"/>
+    <p:sldId xmlns:r="http://schemas.openxmlformats.org/officeDocument/2006/relationships" id="265" r:id="Rc73cf29790494bbe"/>
+    <p:sldId xmlns:r="http://schemas.openxmlformats.org/officeDocument/2006/relationships" id="266" r:id="R0660732379374fbe"/>
+    <p:sldId xmlns:r="http://schemas.openxmlformats.org/officeDocument/2006/relationships" id="267" r:id="R1419737ead4e474e"/>
+    <p:sldId xmlns:r="http://schemas.openxmlformats.org/officeDocument/2006/relationships" id="268" r:id="R821a1c35a2674d7f"/>
+    <p:sldId xmlns:r="http://schemas.openxmlformats.org/officeDocument/2006/relationships" id="269" r:id="R31bb8f916a844a96"/>
   </p:sldIdLst>
   <p:sldSz cx="12192000" cy="6858000"/>
   <p:notesSz cx="6858000" cy="9144000"/>
@@ -455,7 +455,7 @@
           <a:lstStyle xmlns:a="http://schemas.openxmlformats.org/drawingml/2006/main"/>
           <a:p xmlns:a="http://schemas.openxmlformats.org/drawingml/2006/main">
             <a:r>
-              <a:t>가상 식품 제조 ERP 포트폴리오. 실제 Mulino Bianco 프로젝트나 SAP 제품 구현이 아니다. 기본 독자는 SAP/ERP 면접 평가자, 발표 시간은 10–15분이다. 2026-10-06 source 0132e0a. 출처: README.md, docs/portfolio/evidence.json.</a:t>
+              <a:t>가상 식품 제조 ERP 포트폴리오. 실제 Mulino Bianco 프로젝트나 SAP 제품 구현이 아니다. 기본 독자는 SAP/ERP 면접 평가자, 발표 시간은 10–15분이다. 2026-10-06 역사적 Supplier baseline 0132e0a, 현재 Claude 인수 source 4e6935d. 출처: README.md, docs/portfolio/evidence.json.</a:t>
             </a:r>
           </a:p>
         </p:txBody>
@@ -595,7 +595,7 @@
           <a:lstStyle xmlns:a="http://schemas.openxmlformats.org/drawingml/2006/main"/>
           <a:p xmlns:a="http://schemas.openxmlformats.org/drawingml/2006/main">
             <a:r>
-              <a:t>검증량은 업무 인수/규제 완전성을 뜻하지 않는다. Combined validated baseline fe6a51fadd2493018da59babd4a2eea908c2931f: clean test bootJar sitTest,569 discovered/18skip/551 executablePASS, failures0 errors0,20SITPASS/0fail/0skip,8m58s, modelcalls0, JARunchanged. Earlier Supplier0132 checkpoint567/18skip/549PASS remains historical. SIT20=P2P6+QM6+RC6+restart2. Separate #44 tooling: MCP26 runner57 Zig7 CLI32. Original native source2d2a900 runner76/helper7; later logging-only recovery sourcee61ded2 runner82/helper7PASS. Combined551/20 remains fe6 checkpoint, not rerun after recovery logging-only changes. Native worker did not repeat full549 at2d; subsequent combinedfe6 source passed551. Native acceptance remains incomplete. 출처: evidence.json 및 해시로 식별한 supplier/final-report.json, evidence/result.json. 원본 전체 로그는 coordinator 비공개 인수 bundle에 보존한다.</a:t>
+              <a:t>현재 accepted source 4e6935de693b433755e12b4ffcf0197297a6ae31. Full backend checkpoint는 최종 helper·prose CANCEL 교정 전 587 발견/18 제외/569 active PASS 및 bootJar PASS다. 처음 scripted SIT 19/20의 CANCEL 실패는 generic helper가 BLOCK만 허용한 오류이며 보존했다. 최종 helper·prose 교정 뒤 focused22 active/18excluded, full scripted SIT20,bootJar,runner84 PASS다. Full backend는 이 교정만을 위해 재실행하지 않았다. 모델 없는 image smoke/cancellation PASS,modelRequests0. CLI/native/lock bytes는 compact image와 같다. compact17560f2 checkpoint backend562active/SIT20/MCP26/CLI34/Zig7. 과거 fe6a51f551active/SIT20와 Supplier0132 549active는 별도다. 현재 실제 Claude5PASS/21complete native runs와 scripted 검증을 구분한다. 출처: evidence.json nativeUat.currentAccepted.verification, native/manager-stop-1006의 해시로 식별한 담당자 보고서. 원본 로그는 private acceptance bundle에 보존한다.</a:t>
             </a:r>
           </a:p>
         </p:txBody>
@@ -665,7 +665,7 @@
           <a:lstStyle xmlns:a="http://schemas.openxmlformats.org/drawingml/2006/main"/>
           <a:p xmlns:a="http://schemas.openxmlformats.org/drawingml/2006/main">
             <a:r>
-              <a:t>최종 인수/harness source 2d2a900b59a8704e27a4462740196b2c4902829b, production baseline 0132e0a62ad9f086e5c70c5c857d4546f5921ef9. image sha256:aa055d76d0c8d44b9707c84726101e551ec123dc0dba714bea4746b02d4d4656, JAR 4cc3ed1977f72538b51e025b09937f4b122a19e6305f4d0f5a939d82cfbb3369, CLI/role/JAR unchanged. CLAUDE/claude-sonnet-5: P2P001 and002 PASS,004/QM001 FAIL,RC001 INCOMPLETE. P2P002 manager BLOCK reason scenario BLOCK, CaseOPEN/coordinatorABORTED, no separate original decision/work/Attention DB export. 004 PO17000 does not excuse final coordinator MODEL_PROCESS_FAILED and usageComplete=false. QM zero is CLI reported, not imputed. RC rawPASSED preserved but final native usage missing, no valid reacceptance. CODEX/gpt-5.6-sol catalogdefaultlow firstRun fails before proposal, all metrics andresolvedModel unknown, executionReadyfalse/accountingStatusPARTIAL. Current account/rateLimits/read AUTHENTICATION does not establish earlier failure cause. Human login refresh prepared, not executed. Originalattempt knownCLIcostUSD12.661439; latestknownsubtotalUSD12.662505 including diagnostic0.001066, overallunknown. Later Recovery3allFAIL/zeroERPpreserves this original table; see slide14. Historical 2026-10-03 cb04403 Claude3PASS does not establish current acceptance. Source: evidence.json, https://github.com/se0nghe0n/mulino-coreano-erp/blob/2d2a900b59a8704e27a4462740196b2c4902829b/docs/16_scenario_tests.md, https://github.com/se0nghe0n/mulino-coreano-erp/blob/2d2a900b59a8704e27a4462740196b2c4902829b/docs/17_test_classification.md.</a:t>
+              <a:t>현재 clean accepted production source 4e6935de693b433755e12b4ffcf0197297a6ae31, CLAUDE/claude-sonnet-5. image sha256:143e19e38f669ecd6bc0f71c4396008140701e7e57a69c52f9e5f88e520f1567, JAR 11d73935589fee336f6011d5a034e497814bbc917f759e829024e02e59604f2d. 역사적 Supplier0132와 backend/read/role이 달라 runtime unchanged를 주장하지 않는다. P2P001 approved PO1/16500/originalCoordDONE. P2P002 final immutable MANAGER BLOCK/PO0/no reissue/nativeABORTED=receiptABORTED/originalWorkBLOCKED/CaseOPEN/backendJUDGMENTAttention retained. P2P004 oldEXPIRED/PO0 then explicit human recalc/newapprove PO1/17000/originalCoordDONE. QM PENDINGQC/HOLD/quantity2/zeroapplied. RC PENDINGADMIN/raw3/production10/customer2/shipments115/zeroapplied/OFFLINE. 21 unique model_finished/native runs exit0, accountingCOMPLETE/usagecomplete/receiptmatch/denial0. Thisbatch displayed costUSD2.9853428, exactJSONDecimal2.98534280000000011 contains float representation; unknowncost0 onlythisbatch. Historical totals remainunknown. Codex supported account/read refreshTokentrue returned accountnull/requiresOpenaiAuthtrue; rateAUTHENTICATION, no login/start/model calls. Earlier parityFAIL causeunknown. Source: evidence.json nativeUat.currentAccepted and SHA-256 provenance for five-case-summary/per-case JSONs and immutable-provenance-work-attention.jsonl.</a:t>
             </a:r>
           </a:p>
         </p:txBody>
@@ -805,7 +805,7 @@
           <a:lstStyle xmlns:a="http://schemas.openxmlformats.org/drawingml/2006/main"/>
           <a:p xmlns:a="http://schemas.openxmlformats.org/drawingml/2006/main">
             <a:r>
-              <a:t>원래 valid Claude001/002PASS와004/QMFAIL/RCINCOMPLETE를 보존한다. Recovery3 P2P004/QM001/RC001 allFAIL atfirstRun, zeroERP writes, caseOPEN/executionReadyfalse/accountingPARTIAL/usageCompletefalse. Recovery logging source e61ded2e93c0e241be62d87347534503652d74dc, integrated baseline5a6adda, production CLI/role/JAR/image unchanged. NormalRW mount minimalClaude diagnostic success USD0.001066 and USD0.05 cap is not business acceptance. Production/basic no-tool schema probes at USD0.045 cap bothFAIL, same fingerprint 8378c30e44e0ccecc1544d814a0fd4ad9f168c645c2716d0c0c49d52c7f111f0, exactcauseunknown, rawerror discarded. Tools-disabled x structured-output/schema/budget path and0.05vs0.045 cap difference remain caveats, no auth or specifickeyword conclusion. Latestknownreportedsubtotal12.662505, overallunknown. CodexcurrentAUTHENTICATION/humanrefreshNOTexecuted/client35/certgates unchanged. 출처: https://github.com/se0nghe0n/mulino-coreano-erp/blob/e61ded2e93c0e241be62d87347534503652d74dc/docs/15_demo_runbook.md, https://github.com/se0nghe0n/mulino-coreano-erp/blob/e61ded2e93c0e241be62d87347534503652d74dc/docs/16_scenario_tests.md, evidence.json.</a:t>
+              <a:t>현재 Claude5PASS와 과거 인수·진단을 구분한다. Original source2d2a900 2PASS/2FAIL/1INCOMPLETE, recovery3FAIL/zeroERP, canonicalQM native finalization failure and compact17560f2 4PASS/1FAIL retained. Compact002 MANAGER BLOCK kept PO0 but native FAILED due to ambiguous guidance; never convert historical FAILED to ABORTED. Current source provides parent/plan/action/finaldecision and forward-only immutable actor snapshot; legacyUNKNOWN/no backfill. Backend approval and Attention policies unchanged. Minimal Claude/schema newer diagnostics succeeded but are not business acceptance. Earlier failures exact causeunknown. Historical knownCLI subtotal12.662505 preserved, overallcost/tokensunknown. Currentbatch2.9853428/unknowncost0 does not make historical overall complete. Codex prior native parityFAIL causeunknown; supported accountread refreshTokentrue currentnull/requiresAuthtrue/rateAUTH, no login/modelcalls. Actualclient35 pending, OAuth/dashboard excluded, certificate fulltype/auto30day untracked awaiting registration; no MFDS actualtransmission/formvalidation, no productiondeploy/individualIAM/PowerPoint app validation. 출처: evidence.json의 original current/recoveryAttempt와 currentAccepted, docs/15_demo_runbook.md, docs/16_scenario_tests.md.</a:t>
             </a:r>
           </a:p>
         </p:txBody>
@@ -1015,7 +1015,7 @@
           <a:lstStyle xmlns:a="http://schemas.openxmlformats.org/drawingml/2006/main"/>
           <a:p xmlns:a="http://schemas.openxmlformats.org/drawingml/2006/main">
             <a:r>
-              <a:t>source baseline 0132e0a62ad9f086e5c70c5c857d4546f5921ef9. DDL 61개 CREATE TABLE: 원래 ERP 30 + interface 13 + 후속 18. 별도 governance/는 scaffold이며 승인 게이트는 backend에 구현한다. MONITOR reads는 ERP 승인 없이 진행하되 채널 인증과 Case scope를 적용한다. 공유 local role/key는 개인별 운영 IAM이 아니다. #36 결정은 #24/#25 current UAT와 #35 client 인수 전까지 설계 판단이다. 출처: docs/16_decisions.md, https://github.com/se0nghe0n/mulino-coreano-erp/blob/0132e0a62ad9f086e5c70c5c857d4546f5921ef9/mcp-server/src/tools.js, https://github.com/se0nghe0n/mulino-coreano-erp/blob/0132e0a62ad9f086e5c70c5c857d4546f5921ef9/backend/src/main/java/com/mulinocoreano/backend/security/LocalSecurityConfiguration.java, https://github.com/se0nghe0n/mulino-coreano-erp/blob/0132e0a62ad9f086e5c70c5c857d4546f5921ef9/agents/cli/README.md.</a:t>
+              <a:t>역사적 Supplier baseline 0132e0a62ad9f086e5c70c5c857d4546f5921ef9, 현재 accepted production source 4e6935de693b433755e12b4ffcf0197297a6ae31. backend/read/role 변경을 포함한다. DDL 61개 CREATE TABLE: 원래 ERP 30 + interface 13 + 후속 18. 별도 governance/는 scaffold이며 승인 게이트는 backend에 구현한다. MONITOR reads는 ERP 승인 없이 진행하되 채널 인증과 Case scope를 적용한다. 공유 local role/key는 개인별 운영 IAM이 아니다. #24/#25 현재 Claude five-case 인수는 PASS다. #35 actual client 인수는 남아 있다. 출처: docs/16_decisions.md, https://github.com/se0nghe0n/mulino-coreano-erp/blob/0132e0a62ad9f086e5c70c5c857d4546f5921ef9/mcp-server/src/tools.js, https://github.com/se0nghe0n/mulino-coreano-erp/blob/0132e0a62ad9f086e5c70c5c857d4546f5921ef9/backend/src/main/java/com/mulinocoreano/backend/security/LocalSecurityConfiguration.java, https://github.com/se0nghe0n/mulino-coreano-erp/blob/0132e0a62ad9f086e5c70c5c857d4546f5921ef9/agents/cli/README.md.</a:t>
             </a:r>
           </a:p>
         </p:txBody>
@@ -1225,7 +1225,7 @@
           <a:lstStyle xmlns:a="http://schemas.openxmlformats.org/drawingml/2006/main"/>
           <a:p xmlns:a="http://schemas.openxmlformats.org/drawingml/2006/main">
             <a:r>
-              <a:t>scripted SIT QM 6건: 승인·반려·잘못된 역할·인증서/알레르겐·온도/Case 경계를 실제 business state로 확인한다. canonical 22 master / 19 legal categories. Certificate all-required-type and automatic 30-day notices remain gap; don't claim Goal6 complete. 출처: https://github.com/se0nghe0n/mulino-coreano-erp/blob/0132e0a62ad9f086e5c70c5c857d4546f5921ef9/docs/18_inbound_quality_api.md, https://github.com/se0nghe0n/mulino-coreano-erp/blob/0132e0a62ad9f086e5c70c5c857d4546f5921ef9/backend/src/test/resources/scenarios/qm-inbound-inspection.feature, https://github.com/se0nghe0n/mulino-coreano-erp/blob/0132e0a62ad9f086e5c70c5c857d4546f5921ef9/database/seed/allergens.sql.</a:t>
+              <a:t>scripted SIT QM 6건: 승인·반려·잘못된 역할·인증서/알레르겐·온도/Case 경계를 실제 business state로 확인한다. 현재 Claude native QM PASS는 QC 승인안 PENDING, 입고 HOLD·잔량 2·적용 0과 native WAITING/receipt WAITING, 완전 사용량을 확인한다. canonical 22 master / 19 legal categories. Certificate all-required-type and automatic 30-day notices remain gap; don't claim Goal6 complete. 출처: https://github.com/se0nghe0n/mulino-coreano-erp/blob/0132e0a62ad9f086e5c70c5c857d4546f5921ef9/docs/18_inbound_quality_api.md, https://github.com/se0nghe0n/mulino-coreano-erp/blob/0132e0a62ad9f086e5c70c5c857d4546f5921ef9/backend/src/test/resources/scenarios/qm-inbound-inspection.feature, https://github.com/se0nghe0n/mulino-coreano-erp/blob/0132e0a62ad9f086e5c70c5c857d4546f5921ef9/database/seed/allergens.sql.</a:t>
             </a:r>
           </a:p>
         </p:txBody>
@@ -1433,7 +1433,7 @@
   </p:cSld>
   <p:clrMap bg1="lt1" tx1="dk1" bg2="lt2" tx2="dk2" accent1="accent1" accent2="accent2" accent3="accent3" accent4="accent4" accent5="accent5" accent6="accent6" hlink="hlink" folHlink="folHlink"/>
   <p:sldLayoutIdLst>
-    <p:sldLayoutId xmlns:r="http://schemas.openxmlformats.org/officeDocument/2006/relationships" id="2147483649" r:id="R98c0b01572574e74"/>
+    <p:sldLayoutId xmlns:r="http://schemas.openxmlformats.org/officeDocument/2006/relationships" id="2147483649" r:id="R0856747953f94847"/>
   </p:sldLayoutIdLst>
   <p:txStyles>
     <p:titleStyle>
@@ -2166,7 +2166,7 @@
           <p:cNvPr id="6" name="">
             <a:extLst xmlns:a="http://schemas.openxmlformats.org/drawingml/2006/main">
               <a:ext uri="{FF2B5EF4-FFF2-40B4-BE49-F238E27FC236}">
-                <a16:creationId xmlns:a16="http://schemas.microsoft.com/office/drawing/2014/main" id="{6F53F80F-1264-44E9-AF81-32F2EBD350FE}"/>
+                <a16:creationId xmlns:a16="http://schemas.microsoft.com/office/drawing/2014/main" id="{0E3A3F34-8BCE-4A3F-85E5-46BBAAF7F5D6}"/>
               </a:ext>
             </a:extLst>
           </p:cNvPr>
@@ -2223,7 +2223,7 @@
           <p:cNvPr id="2" name="">
             <a:extLst xmlns:a="http://schemas.openxmlformats.org/drawingml/2006/main">
               <a:ext uri="{FF2B5EF4-FFF2-40B4-BE49-F238E27FC236}">
-                <a16:creationId xmlns:a16="http://schemas.microsoft.com/office/drawing/2014/main" id="{2BB90E2D-053B-4EF0-B8E6-B9D38DC1B347}"/>
+                <a16:creationId xmlns:a16="http://schemas.microsoft.com/office/drawing/2014/main" id="{9BFE282D-DABC-410E-A620-453BBEDF9C81}"/>
               </a:ext>
             </a:extLst>
           </p:cNvPr>
@@ -2280,7 +2280,7 @@
           <p:cNvPr id="3" name="">
             <a:extLst xmlns:a="http://schemas.openxmlformats.org/drawingml/2006/main">
               <a:ext uri="{FF2B5EF4-FFF2-40B4-BE49-F238E27FC236}">
-                <a16:creationId xmlns:a16="http://schemas.microsoft.com/office/drawing/2014/main" id="{50FD26EF-35DC-41B7-B01C-C2D0D3007D85}"/>
+                <a16:creationId xmlns:a16="http://schemas.microsoft.com/office/drawing/2014/main" id="{CC273A32-13D8-48A4-8282-120575360748}"/>
               </a:ext>
             </a:extLst>
           </p:cNvPr>
@@ -2360,7 +2360,7 @@
           <p:cNvPr id="4" name="">
             <a:extLst xmlns:a="http://schemas.openxmlformats.org/drawingml/2006/main">
               <a:ext uri="{FF2B5EF4-FFF2-40B4-BE49-F238E27FC236}">
-                <a16:creationId xmlns:a16="http://schemas.microsoft.com/office/drawing/2014/main" id="{271E02B0-42D7-40F3-A50B-0638DCCE49AA}"/>
+                <a16:creationId xmlns:a16="http://schemas.microsoft.com/office/drawing/2014/main" id="{AAB51943-9850-4EB2-B1DA-3288FEE818AF}"/>
               </a:ext>
             </a:extLst>
           </p:cNvPr>
@@ -2417,7 +2417,7 @@
           <p:cNvPr id="5" name="">
             <a:extLst xmlns:a="http://schemas.openxmlformats.org/drawingml/2006/main">
               <a:ext uri="{FF2B5EF4-FFF2-40B4-BE49-F238E27FC236}">
-                <a16:creationId xmlns:a16="http://schemas.microsoft.com/office/drawing/2014/main" id="{25F42A35-019A-4470-9BD4-C3E139631B85}"/>
+                <a16:creationId xmlns:a16="http://schemas.microsoft.com/office/drawing/2014/main" id="{164066D8-25B7-4C1F-9322-E3047AD0F934}"/>
               </a:ext>
             </a:extLst>
           </p:cNvPr>
@@ -2472,7 +2472,7 @@
     </p:spTree>
     <p:extLst>
       <p:ext uri="{BB962C8B-B14F-4D97-AF65-F5344CB8AC3E}">
-        <p14:creationId xmlns:p14="http://schemas.microsoft.com/office/powerpoint/2010/main" val="1919024043"/>
+        <p14:creationId xmlns:p14="http://schemas.microsoft.com/office/powerpoint/2010/main" val="1591102224"/>
       </p:ext>
     </p:extLst>
   </p:cSld>
@@ -2503,7 +2503,7 @@
           <p:cNvPr id="5" name="">
             <a:extLst xmlns:a="http://schemas.openxmlformats.org/drawingml/2006/main">
               <a:ext uri="{FF2B5EF4-FFF2-40B4-BE49-F238E27FC236}">
-                <a16:creationId xmlns:a16="http://schemas.microsoft.com/office/drawing/2014/main" id="{4DF3D715-A99A-4EA3-9149-FDB469A60012}"/>
+                <a16:creationId xmlns:a16="http://schemas.microsoft.com/office/drawing/2014/main" id="{DDECAD77-0278-41DB-AFE7-BD3F669EAA53}"/>
               </a:ext>
             </a:extLst>
           </p:cNvPr>
@@ -2560,7 +2560,7 @@
           <p:cNvPr id="2" name="">
             <a:extLst xmlns:a="http://schemas.openxmlformats.org/drawingml/2006/main">
               <a:ext uri="{FF2B5EF4-FFF2-40B4-BE49-F238E27FC236}">
-                <a16:creationId xmlns:a16="http://schemas.microsoft.com/office/drawing/2014/main" id="{FE5C5163-841D-4809-A372-FD3D5FFC2DC8}"/>
+                <a16:creationId xmlns:a16="http://schemas.microsoft.com/office/drawing/2014/main" id="{E276D096-4D57-485F-94DD-B4CF007A617C}"/>
               </a:ext>
             </a:extLst>
           </p:cNvPr>
@@ -3084,7 +3084,7 @@
           <p:cNvPr id="4" name="">
             <a:extLst xmlns:a="http://schemas.openxmlformats.org/drawingml/2006/main">
               <a:ext uri="{FF2B5EF4-FFF2-40B4-BE49-F238E27FC236}">
-                <a16:creationId xmlns:a16="http://schemas.microsoft.com/office/drawing/2014/main" id="{E40F6A3E-EC46-4907-9D0B-17BC0D821B33}"/>
+                <a16:creationId xmlns:a16="http://schemas.microsoft.com/office/drawing/2014/main" id="{3472EC67-3FBB-47DA-AB57-3C0428A135D3}"/>
               </a:ext>
             </a:extLst>
           </p:cNvPr>
@@ -3139,7 +3139,7 @@
     </p:spTree>
     <p:extLst>
       <p:ext uri="{BB962C8B-B14F-4D97-AF65-F5344CB8AC3E}">
-        <p14:creationId xmlns:p14="http://schemas.microsoft.com/office/powerpoint/2010/main" val="1666185768"/>
+        <p14:creationId xmlns:p14="http://schemas.microsoft.com/office/powerpoint/2010/main" val="1485817865"/>
       </p:ext>
     </p:extLst>
   </p:cSld>
@@ -3170,7 +3170,7 @@
           <p:cNvPr id="9" name="">
             <a:extLst xmlns:a="http://schemas.openxmlformats.org/drawingml/2006/main">
               <a:ext uri="{FF2B5EF4-FFF2-40B4-BE49-F238E27FC236}">
-                <a16:creationId xmlns:a16="http://schemas.microsoft.com/office/drawing/2014/main" id="{F8CBA202-7CFE-4A00-A6B2-DD253EAB04E2}"/>
+                <a16:creationId xmlns:a16="http://schemas.microsoft.com/office/drawing/2014/main" id="{A32090FD-7CC6-4E8C-A0DF-B0247A29F5A9}"/>
               </a:ext>
             </a:extLst>
           </p:cNvPr>
@@ -3227,7 +3227,7 @@
           <p:cNvPr id="2" name="">
             <a:extLst xmlns:a="http://schemas.openxmlformats.org/drawingml/2006/main">
               <a:ext uri="{FF2B5EF4-FFF2-40B4-BE49-F238E27FC236}">
-                <a16:creationId xmlns:a16="http://schemas.microsoft.com/office/drawing/2014/main" id="{38C87091-239B-4D83-BB8A-6A33B20A1233}"/>
+                <a16:creationId xmlns:a16="http://schemas.microsoft.com/office/drawing/2014/main" id="{0CD6C264-81F2-416E-B693-3FB651587AD0}"/>
               </a:ext>
             </a:extLst>
           </p:cNvPr>
@@ -3291,7 +3291,7 @@
         </p:xfrm>
         <a:graphic xmlns:a="http://schemas.openxmlformats.org/drawingml/2006/main">
           <a:graphicData uri="http://schemas.openxmlformats.org/drawingml/2006/chart">
-            <c:chart xmlns:r="http://schemas.openxmlformats.org/officeDocument/2006/relationships" xmlns:c="http://schemas.openxmlformats.org/drawingml/2006/chart" r:id="R123fa86c978142b2"/>
+            <c:chart xmlns:r="http://schemas.openxmlformats.org/officeDocument/2006/relationships" xmlns:c="http://schemas.openxmlformats.org/drawingml/2006/chart" r:id="R6024933078114d6d"/>
           </a:graphicData>
         </a:graphic>
       </p:graphicFrame>
@@ -3300,7 +3300,7 @@
           <p:cNvPr id="4" name="">
             <a:extLst xmlns:a="http://schemas.openxmlformats.org/drawingml/2006/main">
               <a:ext uri="{FF2B5EF4-FFF2-40B4-BE49-F238E27FC236}">
-                <a16:creationId xmlns:a16="http://schemas.microsoft.com/office/drawing/2014/main" id="{B6E8F5FD-4420-4546-B385-7F04CA69C5DE}"/>
+                <a16:creationId xmlns:a16="http://schemas.microsoft.com/office/drawing/2014/main" id="{82E90FA3-64A7-4378-A81E-1C1E9115F2F0}"/>
               </a:ext>
             </a:extLst>
           </p:cNvPr>
@@ -3347,7 +3347,7 @@
                 <a:ea typeface="Apple SD Gothic Neo"/>
                 <a:cs typeface="Apple SD Gothic Neo"/>
               </a:rPr>
-              <a:t>551건 실행 통과</a:t>
+              <a:t>569건 실행 통과</a:t>
             </a:r>
           </a:p>
         </p:txBody>
@@ -3357,7 +3357,7 @@
           <p:cNvPr id="5" name="">
             <a:extLst xmlns:a="http://schemas.openxmlformats.org/drawingml/2006/main">
               <a:ext uri="{FF2B5EF4-FFF2-40B4-BE49-F238E27FC236}">
-                <a16:creationId xmlns:a16="http://schemas.microsoft.com/office/drawing/2014/main" id="{0EAB4E10-E9BC-427C-8384-61A4D8549F65}"/>
+                <a16:creationId xmlns:a16="http://schemas.microsoft.com/office/drawing/2014/main" id="{ADB60DFA-ABB5-41F7-AD26-DE32C766D98C}"/>
               </a:ext>
             </a:extLst>
           </p:cNvPr>
@@ -3404,7 +3404,7 @@
                 <a:ea typeface="Apple SD Gothic Neo"/>
                 <a:cs typeface="Apple SD Gothic Neo"/>
               </a:rPr>
-              <a:t>569건 발견 / 18건 skip</a:t>
+              <a:t>587건 발견 / 18건 제외</a:t>
             </a:r>
           </a:p>
           <a:p xmlns:a="http://schemas.openxmlformats.org/drawingml/2006/main">
@@ -3427,7 +3427,7 @@
                 <a:ea typeface="Apple SD Gothic Neo"/>
                 <a:cs typeface="Apple SD Gothic Neo"/>
               </a:rPr>
-              <a:t>통합 검증 baseline fe6a51f</a:t>
+              <a:t>최종 helper·prose 교정 전</a:t>
             </a:r>
           </a:p>
         </p:txBody>
@@ -3437,7 +3437,7 @@
           <p:cNvPr id="6" name="">
             <a:extLst xmlns:a="http://schemas.openxmlformats.org/drawingml/2006/main">
               <a:ext uri="{FF2B5EF4-FFF2-40B4-BE49-F238E27FC236}">
-                <a16:creationId xmlns:a16="http://schemas.microsoft.com/office/drawing/2014/main" id="{759AD033-5629-47EF-A310-E65AFB8F5D1F}"/>
+                <a16:creationId xmlns:a16="http://schemas.microsoft.com/office/drawing/2014/main" id="{BBCF132D-127B-4933-A69F-3270D7664DC1}"/>
               </a:ext>
             </a:extLst>
           </p:cNvPr>
@@ -3494,7 +3494,7 @@
           <p:cNvPr id="7" name="">
             <a:extLst xmlns:a="http://schemas.openxmlformats.org/drawingml/2006/main">
               <a:ext uri="{FF2B5EF4-FFF2-40B4-BE49-F238E27FC236}">
-                <a16:creationId xmlns:a16="http://schemas.microsoft.com/office/drawing/2014/main" id="{7A3EF104-39D5-4E75-A836-E0558F34AF40}"/>
+                <a16:creationId xmlns:a16="http://schemas.microsoft.com/office/drawing/2014/main" id="{0BFBF1FF-B705-4671-B56B-97F8D584C17A}"/>
               </a:ext>
             </a:extLst>
           </p:cNvPr>
@@ -3541,7 +3541,7 @@
                 <a:ea typeface="Apple SD Gothic Neo"/>
                 <a:cs typeface="Apple SD Gothic Neo"/>
               </a:rPr>
-              <a:t>runner 82 / helper 7</a:t>
+              <a:t>focused 22 / 제외 18</a:t>
             </a:r>
           </a:p>
           <a:p xmlns:a="http://schemas.openxmlformats.org/drawingml/2006/main">
@@ -3564,7 +3564,7 @@
                 <a:ea typeface="Apple SD Gothic Neo"/>
                 <a:cs typeface="Apple SD Gothic Neo"/>
               </a:rPr>
-              <a:t>SIT 20 (fe6 checkpoint)</a:t>
+              <a:t>SIT 20 / runner 84 / bootJar</a:t>
             </a:r>
           </a:p>
           <a:p xmlns:a="http://schemas.openxmlformats.org/drawingml/2006/main">
@@ -3587,7 +3587,7 @@
                 <a:ea typeface="Apple SD Gothic Neo"/>
                 <a:cs typeface="Apple SD Gothic Neo"/>
               </a:rPr>
-              <a:t>#44 MCP 26 / Zig 7 / CLI 32</a:t>
+              <a:t>full backend 재실행 없음</a:t>
             </a:r>
           </a:p>
         </p:txBody>
@@ -3597,7 +3597,7 @@
           <p:cNvPr id="8" name="">
             <a:extLst xmlns:a="http://schemas.openxmlformats.org/drawingml/2006/main">
               <a:ext uri="{FF2B5EF4-FFF2-40B4-BE49-F238E27FC236}">
-                <a16:creationId xmlns:a16="http://schemas.microsoft.com/office/drawing/2014/main" id="{EE9A9F8E-7921-48F0-9481-73F088460111}"/>
+                <a16:creationId xmlns:a16="http://schemas.microsoft.com/office/drawing/2014/main" id="{D32879CA-F518-4704-ADEB-742751C2035E}"/>
               </a:ext>
             </a:extLst>
           </p:cNvPr>
@@ -3652,7 +3652,7 @@
     </p:spTree>
     <p:extLst>
       <p:ext uri="{BB962C8B-B14F-4D97-AF65-F5344CB8AC3E}">
-        <p14:creationId xmlns:p14="http://schemas.microsoft.com/office/powerpoint/2010/main" val="2096169901"/>
+        <p14:creationId xmlns:p14="http://schemas.microsoft.com/office/powerpoint/2010/main" val="1824090003"/>
       </p:ext>
     </p:extLst>
   </p:cSld>
@@ -3683,7 +3683,7 @@
           <p:cNvPr id="5" name="">
             <a:extLst xmlns:a="http://schemas.openxmlformats.org/drawingml/2006/main">
               <a:ext uri="{FF2B5EF4-FFF2-40B4-BE49-F238E27FC236}">
-                <a16:creationId xmlns:a16="http://schemas.microsoft.com/office/drawing/2014/main" id="{0C5D70FD-8742-4B82-8470-0637CB703AF1}"/>
+                <a16:creationId xmlns:a16="http://schemas.microsoft.com/office/drawing/2014/main" id="{2CC7997B-DEDC-4D51-9FB3-2954EA4DFCA7}"/>
               </a:ext>
             </a:extLst>
           </p:cNvPr>
@@ -3730,7 +3730,7 @@
                 <a:ea typeface="Apple SD Gothic Neo"/>
                 <a:cs typeface="Apple SD Gothic Neo"/>
               </a:rPr>
-              <a:t>원래 native UAT 이력: 2 PASS, 전체 인수 미완료</a:t>
+              <a:t>현재 Claude native UAT: 다섯 업무 PASS</a:t>
             </a:r>
           </a:p>
         </p:txBody>
@@ -3740,7 +3740,7 @@
           <p:cNvPr id="2" name="">
             <a:extLst xmlns:a="http://schemas.openxmlformats.org/drawingml/2006/main">
               <a:ext uri="{FF2B5EF4-FFF2-40B4-BE49-F238E27FC236}">
-                <a16:creationId xmlns:a16="http://schemas.microsoft.com/office/drawing/2014/main" id="{205EA969-0CA7-4FC5-9C6D-D7B30B731953}"/>
+                <a16:creationId xmlns:a16="http://schemas.microsoft.com/office/drawing/2014/main" id="{997F9C2F-7C9C-4E39-9DB9-2F510C716D21}"/>
               </a:ext>
             </a:extLst>
           </p:cNvPr>
@@ -3850,7 +3850,7 @@
                           <a:ea typeface="Apple SD Gothic Neo"/>
                           <a:cs typeface="Apple SD Gothic Neo"/>
                         </a:rPr>
-                        <a:t>최종 판정·업무 결과</a:t>
+                        <a:t>현재 판정·업무 결과</a:t>
                       </a:r>
                     </a:p>
                   </a:txBody>
@@ -3924,7 +3924,7 @@
                           <a:ea typeface="Apple SD Gothic Neo"/>
                           <a:cs typeface="Apple SD Gothic Neo"/>
                         </a:rPr>
-                        <a:t>PASS. PO 1 · 16,500원, coordinator DONE</a:t>
+                        <a:t>PASS. 승인 PO 1 · 16,500원, 조정 DONE</a:t>
                       </a:r>
                     </a:p>
                   </a:txBody>
@@ -3948,7 +3948,7 @@
                           <a:ea typeface="Apple SD Gothic Neo"/>
                           <a:cs typeface="Apple SD Gothic Neo"/>
                         </a:rPr>
-                        <a:t>3.0874898</a:t>
+                        <a:t>0.6780952</a:t>
                       </a:r>
                     </a:p>
                   </a:txBody>
@@ -3998,7 +3998,7 @@
                           <a:ea typeface="Apple SD Gothic Neo"/>
                           <a:cs typeface="Apple SD Gothic Neo"/>
                         </a:rPr>
-                        <a:t>PASS. PO·followup 0, MANAGER BLOCK</a:t>
+                        <a:t>PASS. MANAGER BLOCK, PO 0 · ABORTED</a:t>
                       </a:r>
                     </a:p>
                   </a:txBody>
@@ -4022,7 +4022,7 @@
                           <a:ea typeface="Apple SD Gothic Neo"/>
                           <a:cs typeface="Apple SD Gothic Neo"/>
                         </a:rPr>
-                        <a:t>3.2866446</a:t>
+                        <a:t>0.7219284</a:t>
                       </a:r>
                     </a:p>
                   </a:txBody>
@@ -4072,7 +4072,7 @@
                           <a:ea typeface="Apple SD Gothic Neo"/>
                           <a:cs typeface="Apple SD Gothic Neo"/>
                         </a:rPr>
-                        <a:t>FAIL. PO 17,000원 후 최종 조정 실패</a:t>
+                        <a:t>PASS. 만료 후 인간 재계산 · 새 PO 17,000원</a:t>
                       </a:r>
                     </a:p>
                   </a:txBody>
@@ -4096,7 +4096,7 @@
                           <a:ea typeface="Apple SD Gothic Neo"/>
                           <a:cs typeface="Apple SD Gothic Neo"/>
                         </a:rPr>
-                        <a:t>6.2873046</a:t>
+                        <a:t>1.3771636</a:t>
                       </a:r>
                     </a:p>
                   </a:txBody>
@@ -4146,7 +4146,7 @@
                           <a:ea typeface="Apple SD Gothic Neo"/>
                           <a:cs typeface="Apple SD Gothic Neo"/>
                         </a:rPr>
-                        <a:t>FAIL. 검사 제안 전 실행 실패</a:t>
+                        <a:t>PASS. QC PENDING · HOLD 2 · 적용 0</a:t>
                       </a:r>
                     </a:p>
                   </a:txBody>
@@ -4170,7 +4170,7 @@
                           <a:ea typeface="Apple SD Gothic Neo"/>
                           <a:cs typeface="Apple SD Gothic Neo"/>
                         </a:rPr>
-                        <a:t>0 (CLI 보고)</a:t>
+                        <a:t>0.1040890</a:t>
                       </a:r>
                     </a:p>
                   </a:txBody>
@@ -4220,7 +4220,7 @@
                           <a:ea typeface="Apple SD Gothic Neo"/>
                           <a:cs typeface="Apple SD Gothic Neo"/>
                         </a:rPr>
-                        <a:t>INCOMPLETE. native 종료·사용량 누락</a:t>
+                        <a:t>PASS. ADMIN PENDING · 적용 0 · OFFLINE</a:t>
                       </a:r>
                     </a:p>
                   </a:txBody>
@@ -4244,7 +4244,7 @@
                           <a:ea typeface="Apple SD Gothic Neo"/>
                           <a:cs typeface="Apple SD Gothic Neo"/>
                         </a:rPr>
-                        <a:t>unknown</a:t>
+                        <a:t>0.1040666</a:t>
                       </a:r>
                     </a:p>
                   </a:txBody>
@@ -4270,7 +4270,7 @@
                           <a:ea typeface="Apple SD Gothic Neo"/>
                           <a:cs typeface="Apple SD Gothic Neo"/>
                         </a:rPr>
-                        <a:t>Codex P2P-001</a:t>
+                        <a:t>Codex 접근 gate</a:t>
                       </a:r>
                     </a:p>
                   </a:txBody>
@@ -4294,7 +4294,7 @@
                           <a:ea typeface="Apple SD Gothic Neo"/>
                           <a:cs typeface="Apple SD Gothic Neo"/>
                         </a:rPr>
-                        <a:t>FAIL. 제안 전 실행 실패, 사용량 미보고</a:t>
+                        <a:t>account null · 인증 필요, parity 미완료</a:t>
                       </a:r>
                     </a:p>
                   </a:txBody>
@@ -4338,7 +4338,7 @@
           <p:cNvPr id="4" name="">
             <a:extLst xmlns:a="http://schemas.openxmlformats.org/drawingml/2006/main">
               <a:ext uri="{FF2B5EF4-FFF2-40B4-BE49-F238E27FC236}">
-                <a16:creationId xmlns:a16="http://schemas.microsoft.com/office/drawing/2014/main" id="{8E645764-BB15-42FE-940E-E0849C3FCB81}"/>
+                <a16:creationId xmlns:a16="http://schemas.microsoft.com/office/drawing/2014/main" id="{7ED3110A-E1EE-47BC-82DA-09663A1ACB24}"/>
               </a:ext>
             </a:extLst>
           </p:cNvPr>
@@ -4385,7 +4385,7 @@
                 <a:ea typeface="Apple SD Gothic Neo"/>
                 <a:cs typeface="Apple SD Gothic Neo"/>
               </a:rPr>
-              <a:t>원래 시도 소계 USD 12.661439. 최신 알려진 소계 USD 12.662505, 전체 비용 unknown.</a:t>
+              <a:t>현재 batch USD 2.9853428. 21 Run 완전 사용량·receipt 일치·denial 0. 과거 전체 비용 unknown.</a:t>
             </a:r>
           </a:p>
         </p:txBody>
@@ -4393,7 +4393,7 @@
     </p:spTree>
     <p:extLst>
       <p:ext uri="{BB962C8B-B14F-4D97-AF65-F5344CB8AC3E}">
-        <p14:creationId xmlns:p14="http://schemas.microsoft.com/office/powerpoint/2010/main" val="1842255844"/>
+        <p14:creationId xmlns:p14="http://schemas.microsoft.com/office/powerpoint/2010/main" val="994414622"/>
       </p:ext>
     </p:extLst>
   </p:cSld>
@@ -4424,7 +4424,7 @@
           <p:cNvPr id="10" name="">
             <a:extLst xmlns:a="http://schemas.openxmlformats.org/drawingml/2006/main">
               <a:ext uri="{FF2B5EF4-FFF2-40B4-BE49-F238E27FC236}">
-                <a16:creationId xmlns:a16="http://schemas.microsoft.com/office/drawing/2014/main" id="{803FBBB9-0D19-402E-B1F6-59DB273174AE}"/>
+                <a16:creationId xmlns:a16="http://schemas.microsoft.com/office/drawing/2014/main" id="{4F72A5B0-106E-4D38-907F-B6A2678A1A4C}"/>
               </a:ext>
             </a:extLst>
           </p:cNvPr>
@@ -4481,7 +4481,7 @@
           <p:cNvPr id="2" name="">
             <a:extLst xmlns:a="http://schemas.openxmlformats.org/drawingml/2006/main">
               <a:ext uri="{FF2B5EF4-FFF2-40B4-BE49-F238E27FC236}">
-                <a16:creationId xmlns:a16="http://schemas.microsoft.com/office/drawing/2014/main" id="{BA2181B1-8760-47C5-9ECB-B62C666D7BB1}"/>
+                <a16:creationId xmlns:a16="http://schemas.microsoft.com/office/drawing/2014/main" id="{018E3699-20B7-46BF-87A7-69BDE7915BB9}"/>
               </a:ext>
             </a:extLst>
           </p:cNvPr>
@@ -4538,7 +4538,7 @@
           <p:cNvPr id="3" name="">
             <a:extLst xmlns:a="http://schemas.openxmlformats.org/drawingml/2006/main">
               <a:ext uri="{FF2B5EF4-FFF2-40B4-BE49-F238E27FC236}">
-                <a16:creationId xmlns:a16="http://schemas.microsoft.com/office/drawing/2014/main" id="{40C07243-03EE-4D06-8568-A52E80D730A7}"/>
+                <a16:creationId xmlns:a16="http://schemas.microsoft.com/office/drawing/2014/main" id="{09FBCCFE-7C39-426B-8E6A-37342D55092B}"/>
               </a:ext>
             </a:extLst>
           </p:cNvPr>
@@ -4595,7 +4595,7 @@
           <p:cNvPr id="4" name="">
             <a:extLst xmlns:a="http://schemas.openxmlformats.org/drawingml/2006/main">
               <a:ext uri="{FF2B5EF4-FFF2-40B4-BE49-F238E27FC236}">
-                <a16:creationId xmlns:a16="http://schemas.microsoft.com/office/drawing/2014/main" id="{7C2FB43C-581B-47DC-80E3-DA20D93C729F}"/>
+                <a16:creationId xmlns:a16="http://schemas.microsoft.com/office/drawing/2014/main" id="{E8952485-8A49-4623-B6EE-A9B1DEA76D4D}"/>
               </a:ext>
             </a:extLst>
           </p:cNvPr>
@@ -4652,7 +4652,7 @@
           <p:cNvPr id="5" name="">
             <a:extLst xmlns:a="http://schemas.openxmlformats.org/drawingml/2006/main">
               <a:ext uri="{FF2B5EF4-FFF2-40B4-BE49-F238E27FC236}">
-                <a16:creationId xmlns:a16="http://schemas.microsoft.com/office/drawing/2014/main" id="{1481685A-5E91-4A8B-9063-EE6970E95C06}"/>
+                <a16:creationId xmlns:a16="http://schemas.microsoft.com/office/drawing/2014/main" id="{DAF72797-2490-426D-84F8-5192A5F60273}"/>
               </a:ext>
             </a:extLst>
           </p:cNvPr>
@@ -4709,7 +4709,7 @@
           <p:cNvPr id="6" name="">
             <a:extLst xmlns:a="http://schemas.openxmlformats.org/drawingml/2006/main">
               <a:ext uri="{FF2B5EF4-FFF2-40B4-BE49-F238E27FC236}">
-                <a16:creationId xmlns:a16="http://schemas.microsoft.com/office/drawing/2014/main" id="{70CD32B9-8BF3-45E9-A395-6808E3F30523}"/>
+                <a16:creationId xmlns:a16="http://schemas.microsoft.com/office/drawing/2014/main" id="{451375E4-9A17-4156-A094-A42D582A02F2}"/>
               </a:ext>
             </a:extLst>
           </p:cNvPr>
@@ -4766,7 +4766,7 @@
           <p:cNvPr id="7" name="">
             <a:extLst xmlns:a="http://schemas.openxmlformats.org/drawingml/2006/main">
               <a:ext uri="{FF2B5EF4-FFF2-40B4-BE49-F238E27FC236}">
-                <a16:creationId xmlns:a16="http://schemas.microsoft.com/office/drawing/2014/main" id="{2D05A19B-62F2-41A4-B82B-8897703706CF}"/>
+                <a16:creationId xmlns:a16="http://schemas.microsoft.com/office/drawing/2014/main" id="{5DC10F55-7DCF-4D65-9B6B-FCCA5042ED5A}"/>
               </a:ext>
             </a:extLst>
           </p:cNvPr>
@@ -4823,7 +4823,7 @@
           <p:cNvPr id="8" name="">
             <a:extLst xmlns:a="http://schemas.openxmlformats.org/drawingml/2006/main">
               <a:ext uri="{FF2B5EF4-FFF2-40B4-BE49-F238E27FC236}">
-                <a16:creationId xmlns:a16="http://schemas.microsoft.com/office/drawing/2014/main" id="{13DEDDF0-13D0-40A7-B832-B496D9820B7B}"/>
+                <a16:creationId xmlns:a16="http://schemas.microsoft.com/office/drawing/2014/main" id="{5B7D3A33-2D9D-4C9A-A8F5-53FE13A7E7B6}"/>
               </a:ext>
             </a:extLst>
           </p:cNvPr>
@@ -4880,7 +4880,7 @@
           <p:cNvPr id="9" name="">
             <a:extLst xmlns:a="http://schemas.openxmlformats.org/drawingml/2006/main">
               <a:ext uri="{FF2B5EF4-FFF2-40B4-BE49-F238E27FC236}">
-                <a16:creationId xmlns:a16="http://schemas.microsoft.com/office/drawing/2014/main" id="{8A7B7A32-75FF-463E-A294-48466A5CC606}"/>
+                <a16:creationId xmlns:a16="http://schemas.microsoft.com/office/drawing/2014/main" id="{A1706BEE-AF11-4BAD-9184-BA093FF44FB1}"/>
               </a:ext>
             </a:extLst>
           </p:cNvPr>
@@ -4935,7 +4935,7 @@
     </p:spTree>
     <p:extLst>
       <p:ext uri="{BB962C8B-B14F-4D97-AF65-F5344CB8AC3E}">
-        <p14:creationId xmlns:p14="http://schemas.microsoft.com/office/powerpoint/2010/main" val="1262414515"/>
+        <p14:creationId xmlns:p14="http://schemas.microsoft.com/office/powerpoint/2010/main" val="307447691"/>
       </p:ext>
     </p:extLst>
   </p:cSld>
@@ -4966,7 +4966,7 @@
           <p:cNvPr id="10" name="">
             <a:extLst xmlns:a="http://schemas.openxmlformats.org/drawingml/2006/main">
               <a:ext uri="{FF2B5EF4-FFF2-40B4-BE49-F238E27FC236}">
-                <a16:creationId xmlns:a16="http://schemas.microsoft.com/office/drawing/2014/main" id="{7BFD2018-5DB5-4BA0-8B92-A82D9561AC5C}"/>
+                <a16:creationId xmlns:a16="http://schemas.microsoft.com/office/drawing/2014/main" id="{B7A86EBD-689E-43C3-9486-2E33378D1FD6}"/>
               </a:ext>
             </a:extLst>
           </p:cNvPr>
@@ -5013,7 +5013,7 @@
                 <a:ea typeface="Apple SD Gothic Neo"/>
                 <a:cs typeface="Apple SD Gothic Neo"/>
               </a:rPr>
-              <a:t>Recovery 실패와 남은 runtime 인수 gate</a:t>
+              <a:t>보존한 실패 이력과 남은 인수 gate</a:t>
             </a:r>
           </a:p>
         </p:txBody>
@@ -5023,7 +5023,7 @@
           <p:cNvPr id="2" name="">
             <a:extLst xmlns:a="http://schemas.openxmlformats.org/drawingml/2006/main">
               <a:ext uri="{FF2B5EF4-FFF2-40B4-BE49-F238E27FC236}">
-                <a16:creationId xmlns:a16="http://schemas.microsoft.com/office/drawing/2014/main" id="{A2A3390A-4FB8-4514-8874-148311E77E0A}"/>
+                <a16:creationId xmlns:a16="http://schemas.microsoft.com/office/drawing/2014/main" id="{8DCD97AD-C196-4806-9429-F7CEB687BC1F}"/>
               </a:ext>
             </a:extLst>
           </p:cNvPr>
@@ -5080,7 +5080,7 @@
           <p:cNvPr id="3" name="">
             <a:extLst xmlns:a="http://schemas.openxmlformats.org/drawingml/2006/main">
               <a:ext uri="{FF2B5EF4-FFF2-40B4-BE49-F238E27FC236}">
-                <a16:creationId xmlns:a16="http://schemas.microsoft.com/office/drawing/2014/main" id="{FA1D1AEA-5D7F-497D-BD2D-9227489D4C84}"/>
+                <a16:creationId xmlns:a16="http://schemas.microsoft.com/office/drawing/2014/main" id="{5DE8DB1D-85BD-4E31-A60A-F69E335F938D}"/>
               </a:ext>
             </a:extLst>
           </p:cNvPr>
@@ -5127,7 +5127,7 @@
                 <a:ea typeface="Apple SD Gothic Neo"/>
                 <a:cs typeface="Apple SD Gothic Neo"/>
               </a:rPr>
-              <a:t>유효한 PASS와 재시도 실패를 보존한다</a:t>
+              <a:t>원래 실패와 이후 재시도를 보존한다</a:t>
             </a:r>
           </a:p>
         </p:txBody>
@@ -5137,7 +5137,7 @@
           <p:cNvPr id="4" name="">
             <a:extLst xmlns:a="http://schemas.openxmlformats.org/drawingml/2006/main">
               <a:ext uri="{FF2B5EF4-FFF2-40B4-BE49-F238E27FC236}">
-                <a16:creationId xmlns:a16="http://schemas.microsoft.com/office/drawing/2014/main" id="{6D9BC72F-D51A-48D6-8B08-BDCD3B321A3A}"/>
+                <a16:creationId xmlns:a16="http://schemas.microsoft.com/office/drawing/2014/main" id="{6F01071A-81A4-4EA2-BCD2-60F77860E234}"/>
               </a:ext>
             </a:extLst>
           </p:cNvPr>
@@ -5184,7 +5184,7 @@
                 <a:ea typeface="Apple SD Gothic Neo"/>
                 <a:cs typeface="Apple SD Gothic Neo"/>
               </a:rPr>
-              <a:t>001·002는 PASS다. 004·QM·RC의 Recovery 3건은 모두 FAIL, ERP 쓰기 0건이다.</a:t>
+              <a:t>원래 2 PASS·2 FAIL·1 INCOMPLETE, Recovery 3 FAIL, compact 4 PASS·1 FAIL을 남긴다.</a:t>
             </a:r>
           </a:p>
         </p:txBody>
@@ -5194,7 +5194,7 @@
           <p:cNvPr id="5" name="">
             <a:extLst xmlns:a="http://schemas.openxmlformats.org/drawingml/2006/main">
               <a:ext uri="{FF2B5EF4-FFF2-40B4-BE49-F238E27FC236}">
-                <a16:creationId xmlns:a16="http://schemas.microsoft.com/office/drawing/2014/main" id="{F5244B84-6F21-4A16-9CA6-AB20E7B5BCC5}"/>
+                <a16:creationId xmlns:a16="http://schemas.microsoft.com/office/drawing/2014/main" id="{C615208D-77FF-4E03-9E0C-514B49F42FF8}"/>
               </a:ext>
             </a:extLst>
           </p:cNvPr>
@@ -5241,7 +5241,7 @@
                 <a:ea typeface="Apple SD Gothic Neo"/>
                 <a:cs typeface="Apple SD Gothic Neo"/>
               </a:rPr>
-              <a:t>최소 진단 성공을 업무 인수로 세지 않는다</a:t>
+              <a:t>현재 Claude 업무 인수와 진단을 구분한다</a:t>
             </a:r>
           </a:p>
         </p:txBody>
@@ -5251,7 +5251,7 @@
           <p:cNvPr id="6" name="">
             <a:extLst xmlns:a="http://schemas.openxmlformats.org/drawingml/2006/main">
               <a:ext uri="{FF2B5EF4-FFF2-40B4-BE49-F238E27FC236}">
-                <a16:creationId xmlns:a16="http://schemas.microsoft.com/office/drawing/2014/main" id="{902CABB5-4C0E-4954-974A-07E14F9C49EF}"/>
+                <a16:creationId xmlns:a16="http://schemas.microsoft.com/office/drawing/2014/main" id="{5B83F972-A740-4AE3-B3E6-0EBF6B74F4FA}"/>
               </a:ext>
             </a:extLst>
           </p:cNvPr>
@@ -5298,7 +5298,7 @@
                 <a:ea typeface="Apple SD Gothic Neo"/>
                 <a:cs typeface="Apple SD Gothic Neo"/>
               </a:rPr>
-              <a:t>RW 최소 진단 USD 0.001066 성공. no-tool production/basic probe는 둘 다 FAIL이다.</a:t>
+              <a:t>현재 다섯 PASS는 업무·native 종료를 검증했다. 최소 Claude/schema 진단은 별도다.</a:t>
             </a:r>
           </a:p>
         </p:txBody>
@@ -5308,7 +5308,7 @@
           <p:cNvPr id="7" name="">
             <a:extLst xmlns:a="http://schemas.openxmlformats.org/drawingml/2006/main">
               <a:ext uri="{FF2B5EF4-FFF2-40B4-BE49-F238E27FC236}">
-                <a16:creationId xmlns:a16="http://schemas.microsoft.com/office/drawing/2014/main" id="{B2630CC1-BF93-4491-A0F3-75AA30CC2686}"/>
+                <a16:creationId xmlns:a16="http://schemas.microsoft.com/office/drawing/2014/main" id="{18D82729-44B9-4B3D-AFE2-5DF6F10B5090}"/>
               </a:ext>
             </a:extLst>
           </p:cNvPr>
@@ -5355,7 +5355,7 @@
                 <a:ea typeface="Apple SD Gothic Neo"/>
                 <a:cs typeface="Apple SD Gothic Neo"/>
               </a:rPr>
-              <a:t>정확한 실패 원인은 unknown이다</a:t>
+              <a:t>Codex와 실제 클라이언트 인수가 남아 있다</a:t>
             </a:r>
           </a:p>
         </p:txBody>
@@ -5365,7 +5365,7 @@
           <p:cNvPr id="8" name="">
             <a:extLst xmlns:a="http://schemas.openxmlformats.org/drawingml/2006/main">
               <a:ext uri="{FF2B5EF4-FFF2-40B4-BE49-F238E27FC236}">
-                <a16:creationId xmlns:a16="http://schemas.microsoft.com/office/drawing/2014/main" id="{6D937E13-878C-4012-AA20-5A4D6DC3B899}"/>
+                <a16:creationId xmlns:a16="http://schemas.microsoft.com/office/drawing/2014/main" id="{490B2D64-BFE0-4CAF-8117-A8990D1FED1B}"/>
               </a:ext>
             </a:extLst>
           </p:cNvPr>
@@ -5412,7 +5412,7 @@
                 <a:ea typeface="Apple SD Gothic Neo"/>
                 <a:cs typeface="Apple SD Gothic Neo"/>
               </a:rPr>
-              <a:t>같은 fingerprint만 확인했다. tools-disabled·schema·budget 경로는 미해소다.</a:t>
+              <a:t>Codex account 인증 gate와 #35를 해소하지 않았다. 규제·운영 인수는 별도다.</a:t>
             </a:r>
           </a:p>
         </p:txBody>
@@ -5422,7 +5422,7 @@
           <p:cNvPr id="9" name="">
             <a:extLst xmlns:a="http://schemas.openxmlformats.org/drawingml/2006/main">
               <a:ext uri="{FF2B5EF4-FFF2-40B4-BE49-F238E27FC236}">
-                <a16:creationId xmlns:a16="http://schemas.microsoft.com/office/drawing/2014/main" id="{6F3D9D09-8FE5-40EC-AF42-FC810FAF5730}"/>
+                <a16:creationId xmlns:a16="http://schemas.microsoft.com/office/drawing/2014/main" id="{3D8EDC24-C600-478D-8C59-2CEF05EF18A0}"/>
               </a:ext>
             </a:extLst>
           </p:cNvPr>
@@ -5469,7 +5469,7 @@
                 <a:ea typeface="Apple SD Gothic Neo"/>
                 <a:cs typeface="Apple SD Gothic Neo"/>
               </a:rPr>
-              <a:t>Codex AUTHENTICATION·인간 login 갱신 미실행. 최신 소계 USD 12.662505, 전체 비용 unknown.</a:t>
+              <a:t>이전 실패 원인·역사적 전체 비용은 unknown이다. 현재 five-case PASS로 과거 기록을 덮어쓰지 않는다.</a:t>
             </a:r>
           </a:p>
         </p:txBody>
@@ -5477,7 +5477,7 @@
     </p:spTree>
     <p:extLst>
       <p:ext uri="{BB962C8B-B14F-4D97-AF65-F5344CB8AC3E}">
-        <p14:creationId xmlns:p14="http://schemas.microsoft.com/office/powerpoint/2010/main" val="1062955570"/>
+        <p14:creationId xmlns:p14="http://schemas.microsoft.com/office/powerpoint/2010/main" val="770519817"/>
       </p:ext>
     </p:extLst>
   </p:cSld>
@@ -5508,7 +5508,7 @@
           <p:cNvPr id="5" name="">
             <a:extLst xmlns:a="http://schemas.openxmlformats.org/drawingml/2006/main">
               <a:ext uri="{FF2B5EF4-FFF2-40B4-BE49-F238E27FC236}">
-                <a16:creationId xmlns:a16="http://schemas.microsoft.com/office/drawing/2014/main" id="{04C00F79-CFC1-46FC-9D94-58B060665DBD}"/>
+                <a16:creationId xmlns:a16="http://schemas.microsoft.com/office/drawing/2014/main" id="{0D888E4F-8A95-4D79-ABC9-73E4781C150F}"/>
               </a:ext>
             </a:extLst>
           </p:cNvPr>
@@ -5565,7 +5565,7 @@
           <p:cNvPr id="2" name="">
             <a:extLst xmlns:a="http://schemas.openxmlformats.org/drawingml/2006/main">
               <a:ext uri="{FF2B5EF4-FFF2-40B4-BE49-F238E27FC236}">
-                <a16:creationId xmlns:a16="http://schemas.microsoft.com/office/drawing/2014/main" id="{C4D91056-F6E6-447A-8C17-F396B4DDC8BC}"/>
+                <a16:creationId xmlns:a16="http://schemas.microsoft.com/office/drawing/2014/main" id="{D7B5BAB1-E8CB-4A3B-AFDD-D967F5E87982}"/>
               </a:ext>
             </a:extLst>
           </p:cNvPr>
@@ -6089,7 +6089,7 @@
           <p:cNvPr id="4" name="">
             <a:extLst xmlns:a="http://schemas.openxmlformats.org/drawingml/2006/main">
               <a:ext uri="{FF2B5EF4-FFF2-40B4-BE49-F238E27FC236}">
-                <a16:creationId xmlns:a16="http://schemas.microsoft.com/office/drawing/2014/main" id="{CC98A845-7762-415C-A7D1-35ECE017A084}"/>
+                <a16:creationId xmlns:a16="http://schemas.microsoft.com/office/drawing/2014/main" id="{37822217-AD49-44FF-972E-E59E4C4B4EFB}"/>
               </a:ext>
             </a:extLst>
           </p:cNvPr>
@@ -6144,7 +6144,7 @@
     </p:spTree>
     <p:extLst>
       <p:ext uri="{BB962C8B-B14F-4D97-AF65-F5344CB8AC3E}">
-        <p14:creationId xmlns:p14="http://schemas.microsoft.com/office/powerpoint/2010/main" val="1901063976"/>
+        <p14:creationId xmlns:p14="http://schemas.microsoft.com/office/powerpoint/2010/main" val="1264299318"/>
       </p:ext>
     </p:extLst>
   </p:cSld>
@@ -6175,7 +6175,7 @@
           <p:cNvPr id="5" name="">
             <a:extLst xmlns:a="http://schemas.openxmlformats.org/drawingml/2006/main">
               <a:ext uri="{FF2B5EF4-FFF2-40B4-BE49-F238E27FC236}">
-                <a16:creationId xmlns:a16="http://schemas.microsoft.com/office/drawing/2014/main" id="{4D02C316-3C78-465E-8710-CDF0446A6A6F}"/>
+                <a16:creationId xmlns:a16="http://schemas.microsoft.com/office/drawing/2014/main" id="{81F3ACA7-EC5A-4083-B4CA-2BEBB972C754}"/>
               </a:ext>
             </a:extLst>
           </p:cNvPr>
@@ -6232,7 +6232,7 @@
           <p:cNvPr id="2" name="">
             <a:extLst xmlns:a="http://schemas.openxmlformats.org/drawingml/2006/main">
               <a:ext uri="{FF2B5EF4-FFF2-40B4-BE49-F238E27FC236}">
-                <a16:creationId xmlns:a16="http://schemas.microsoft.com/office/drawing/2014/main" id="{3CAB2A3E-D4B8-4322-8D2E-A390C7A79F98}"/>
+                <a16:creationId xmlns:a16="http://schemas.microsoft.com/office/drawing/2014/main" id="{8B11FE25-7190-4AD1-B76D-D5D1B1659972}"/>
               </a:ext>
             </a:extLst>
           </p:cNvPr>
@@ -6830,7 +6830,7 @@
           <p:cNvPr id="4" name="">
             <a:extLst xmlns:a="http://schemas.openxmlformats.org/drawingml/2006/main">
               <a:ext uri="{FF2B5EF4-FFF2-40B4-BE49-F238E27FC236}">
-                <a16:creationId xmlns:a16="http://schemas.microsoft.com/office/drawing/2014/main" id="{178780FC-52F4-4B9C-B33C-B0BCF2FBC5D2}"/>
+                <a16:creationId xmlns:a16="http://schemas.microsoft.com/office/drawing/2014/main" id="{40ABF6CC-9B55-4252-B14A-690E4712E0F4}"/>
               </a:ext>
             </a:extLst>
           </p:cNvPr>
@@ -6885,7 +6885,7 @@
     </p:spTree>
     <p:extLst>
       <p:ext uri="{BB962C8B-B14F-4D97-AF65-F5344CB8AC3E}">
-        <p14:creationId xmlns:p14="http://schemas.microsoft.com/office/powerpoint/2010/main" val="4942086"/>
+        <p14:creationId xmlns:p14="http://schemas.microsoft.com/office/powerpoint/2010/main" val="1987716295"/>
       </p:ext>
     </p:extLst>
   </p:cSld>
@@ -6916,7 +6916,7 @@
           <p:cNvPr id="13" name="">
             <a:extLst xmlns:a="http://schemas.openxmlformats.org/drawingml/2006/main">
               <a:ext uri="{FF2B5EF4-FFF2-40B4-BE49-F238E27FC236}">
-                <a16:creationId xmlns:a16="http://schemas.microsoft.com/office/drawing/2014/main" id="{D57D2E92-9885-438B-BD84-A3A99990375D}"/>
+                <a16:creationId xmlns:a16="http://schemas.microsoft.com/office/drawing/2014/main" id="{7A12B2DC-2D15-40ED-8889-66F346598E77}"/>
               </a:ext>
             </a:extLst>
           </p:cNvPr>
@@ -6973,7 +6973,7 @@
           <p:cNvPr id="2" name="">
             <a:extLst xmlns:a="http://schemas.openxmlformats.org/drawingml/2006/main">
               <a:ext uri="{FF2B5EF4-FFF2-40B4-BE49-F238E27FC236}">
-                <a16:creationId xmlns:a16="http://schemas.microsoft.com/office/drawing/2014/main" id="{33D89B27-2D51-4F50-81DF-98FC453AA58A}"/>
+                <a16:creationId xmlns:a16="http://schemas.microsoft.com/office/drawing/2014/main" id="{AE35FD6A-AA17-471E-B5F1-BD58D89BFA0D}"/>
               </a:ext>
             </a:extLst>
           </p:cNvPr>
@@ -7030,7 +7030,7 @@
           <p:cNvPr id="3" name="">
             <a:extLst xmlns:a="http://schemas.openxmlformats.org/drawingml/2006/main">
               <a:ext uri="{FF2B5EF4-FFF2-40B4-BE49-F238E27FC236}">
-                <a16:creationId xmlns:a16="http://schemas.microsoft.com/office/drawing/2014/main" id="{3C50A298-D604-4BA7-B119-7167DF696CFA}"/>
+                <a16:creationId xmlns:a16="http://schemas.microsoft.com/office/drawing/2014/main" id="{0F5C2AB8-41F2-4DE4-81B1-57FC88C6AA93}"/>
               </a:ext>
             </a:extLst>
           </p:cNvPr>
@@ -7112,7 +7112,7 @@
           <p:cNvPr id="4" name="">
             <a:extLst xmlns:a="http://schemas.openxmlformats.org/drawingml/2006/main">
               <a:ext uri="{FF2B5EF4-FFF2-40B4-BE49-F238E27FC236}">
-                <a16:creationId xmlns:a16="http://schemas.microsoft.com/office/drawing/2014/main" id="{284371E0-B538-48CF-84B9-241C502CC10E}"/>
+                <a16:creationId xmlns:a16="http://schemas.microsoft.com/office/drawing/2014/main" id="{EEC448AA-CDEC-4F93-8C71-23501723F866}"/>
               </a:ext>
             </a:extLst>
           </p:cNvPr>
@@ -7194,7 +7194,7 @@
           <p:cNvPr id="5" name="">
             <a:extLst xmlns:a="http://schemas.openxmlformats.org/drawingml/2006/main">
               <a:ext uri="{FF2B5EF4-FFF2-40B4-BE49-F238E27FC236}">
-                <a16:creationId xmlns:a16="http://schemas.microsoft.com/office/drawing/2014/main" id="{E1513D98-DA18-44E8-BA84-DB0293ED9663}"/>
+                <a16:creationId xmlns:a16="http://schemas.microsoft.com/office/drawing/2014/main" id="{6E238620-0FD6-4C00-BDE1-6C46DEEC12BE}"/>
               </a:ext>
             </a:extLst>
           </p:cNvPr>
@@ -7276,7 +7276,7 @@
           <p:cNvPr id="6" name="">
             <a:extLst xmlns:a="http://schemas.openxmlformats.org/drawingml/2006/main">
               <a:ext uri="{FF2B5EF4-FFF2-40B4-BE49-F238E27FC236}">
-                <a16:creationId xmlns:a16="http://schemas.microsoft.com/office/drawing/2014/main" id="{4F7D33BC-B60A-4F50-B419-53059C2A74DF}"/>
+                <a16:creationId xmlns:a16="http://schemas.microsoft.com/office/drawing/2014/main" id="{1B066783-3B8E-4CEE-8BD3-0FB3890C0056}"/>
               </a:ext>
             </a:extLst>
           </p:cNvPr>
@@ -7306,7 +7306,7 @@
           <p:cNvPr id="7" name="">
             <a:extLst xmlns:a="http://schemas.openxmlformats.org/drawingml/2006/main">
               <a:ext uri="{FF2B5EF4-FFF2-40B4-BE49-F238E27FC236}">
-                <a16:creationId xmlns:a16="http://schemas.microsoft.com/office/drawing/2014/main" id="{FE9A7DF8-4429-42DB-99D3-D042BEAC8EA7}"/>
+                <a16:creationId xmlns:a16="http://schemas.microsoft.com/office/drawing/2014/main" id="{9F0EFC5A-C9AC-4E30-BF65-141E58561EEF}"/>
               </a:ext>
             </a:extLst>
           </p:cNvPr>
@@ -7336,7 +7336,7 @@
           <p:cNvPr id="8" name="">
             <a:extLst xmlns:a="http://schemas.openxmlformats.org/drawingml/2006/main">
               <a:ext uri="{FF2B5EF4-FFF2-40B4-BE49-F238E27FC236}">
-                <a16:creationId xmlns:a16="http://schemas.microsoft.com/office/drawing/2014/main" id="{AA4002FA-077C-4FF6-BF62-F7C6216CB32F}"/>
+                <a16:creationId xmlns:a16="http://schemas.microsoft.com/office/drawing/2014/main" id="{F5350F13-2B61-415B-AF25-D1CB6AC741C2}"/>
               </a:ext>
             </a:extLst>
           </p:cNvPr>
@@ -7366,7 +7366,7 @@
           <p:cNvPr id="9" name="">
             <a:extLst xmlns:a="http://schemas.openxmlformats.org/drawingml/2006/main">
               <a:ext uri="{FF2B5EF4-FFF2-40B4-BE49-F238E27FC236}">
-                <a16:creationId xmlns:a16="http://schemas.microsoft.com/office/drawing/2014/main" id="{D2C6CB81-C7D6-4FA2-844B-9612608C1DF3}"/>
+                <a16:creationId xmlns:a16="http://schemas.microsoft.com/office/drawing/2014/main" id="{3573F175-5F14-4F22-82E7-D0335FAB8D2E}"/>
               </a:ext>
             </a:extLst>
           </p:cNvPr>
@@ -7425,7 +7425,7 @@
           <p:cNvPr id="10" name="">
             <a:extLst xmlns:a="http://schemas.openxmlformats.org/drawingml/2006/main">
               <a:ext uri="{FF2B5EF4-FFF2-40B4-BE49-F238E27FC236}">
-                <a16:creationId xmlns:a16="http://schemas.microsoft.com/office/drawing/2014/main" id="{18F985CD-7202-41B0-8B81-6313896822C1}"/>
+                <a16:creationId xmlns:a16="http://schemas.microsoft.com/office/drawing/2014/main" id="{82DBF5B7-226E-4798-9B5C-26AAA882A702}"/>
               </a:ext>
             </a:extLst>
           </p:cNvPr>
@@ -7455,7 +7455,7 @@
           <p:cNvPr id="11" name="">
             <a:extLst xmlns:a="http://schemas.openxmlformats.org/drawingml/2006/main">
               <a:ext uri="{FF2B5EF4-FFF2-40B4-BE49-F238E27FC236}">
-                <a16:creationId xmlns:a16="http://schemas.microsoft.com/office/drawing/2014/main" id="{2948134D-6C50-453B-82FA-E2DE78293AF1}"/>
+                <a16:creationId xmlns:a16="http://schemas.microsoft.com/office/drawing/2014/main" id="{AEC636EA-77E5-41AA-A21F-B80689A8AA27}"/>
               </a:ext>
             </a:extLst>
           </p:cNvPr>
@@ -7514,7 +7514,7 @@
           <p:cNvPr id="12" name="">
             <a:extLst xmlns:a="http://schemas.openxmlformats.org/drawingml/2006/main">
               <a:ext uri="{FF2B5EF4-FFF2-40B4-BE49-F238E27FC236}">
-                <a16:creationId xmlns:a16="http://schemas.microsoft.com/office/drawing/2014/main" id="{6D64D17A-B504-4BA2-A796-18899F0C5307}"/>
+                <a16:creationId xmlns:a16="http://schemas.microsoft.com/office/drawing/2014/main" id="{EF2F2F14-94F2-4BCE-B747-6B6B89F7EE0F}"/>
               </a:ext>
             </a:extLst>
           </p:cNvPr>
@@ -7569,7 +7569,7 @@
     </p:spTree>
     <p:extLst>
       <p:ext uri="{BB962C8B-B14F-4D97-AF65-F5344CB8AC3E}">
-        <p14:creationId xmlns:p14="http://schemas.microsoft.com/office/powerpoint/2010/main" val="2083228185"/>
+        <p14:creationId xmlns:p14="http://schemas.microsoft.com/office/powerpoint/2010/main" val="1778547373"/>
       </p:ext>
     </p:extLst>
   </p:cSld>
@@ -7600,7 +7600,7 @@
           <p:cNvPr id="13" name="">
             <a:extLst xmlns:a="http://schemas.openxmlformats.org/drawingml/2006/main">
               <a:ext uri="{FF2B5EF4-FFF2-40B4-BE49-F238E27FC236}">
-                <a16:creationId xmlns:a16="http://schemas.microsoft.com/office/drawing/2014/main" id="{A4BF5FA5-3E0C-4B47-A871-CE624BE47F70}"/>
+                <a16:creationId xmlns:a16="http://schemas.microsoft.com/office/drawing/2014/main" id="{A5C793CE-42F1-46BE-92E2-7F455807CFF3}"/>
               </a:ext>
             </a:extLst>
           </p:cNvPr>
@@ -7657,7 +7657,7 @@
           <p:cNvPr id="2" name="">
             <a:extLst xmlns:a="http://schemas.openxmlformats.org/drawingml/2006/main">
               <a:ext uri="{FF2B5EF4-FFF2-40B4-BE49-F238E27FC236}">
-                <a16:creationId xmlns:a16="http://schemas.microsoft.com/office/drawing/2014/main" id="{451CC574-F4AA-41B7-8243-1A5AC715AFD2}"/>
+                <a16:creationId xmlns:a16="http://schemas.microsoft.com/office/drawing/2014/main" id="{DCB8F50D-EC82-41E2-9A8E-DFC27E5EE4FD}"/>
               </a:ext>
             </a:extLst>
           </p:cNvPr>
@@ -7714,7 +7714,7 @@
           <p:cNvPr id="3" name="">
             <a:extLst xmlns:a="http://schemas.openxmlformats.org/drawingml/2006/main">
               <a:ext uri="{FF2B5EF4-FFF2-40B4-BE49-F238E27FC236}">
-                <a16:creationId xmlns:a16="http://schemas.microsoft.com/office/drawing/2014/main" id="{132CE39B-C955-43A6-A6D7-15B49E51A05A}"/>
+                <a16:creationId xmlns:a16="http://schemas.microsoft.com/office/drawing/2014/main" id="{01A7ED87-4F70-4DD9-BECA-F85BE4732787}"/>
               </a:ext>
             </a:extLst>
           </p:cNvPr>
@@ -7796,7 +7796,7 @@
           <p:cNvPr id="4" name="">
             <a:extLst xmlns:a="http://schemas.openxmlformats.org/drawingml/2006/main">
               <a:ext uri="{FF2B5EF4-FFF2-40B4-BE49-F238E27FC236}">
-                <a16:creationId xmlns:a16="http://schemas.microsoft.com/office/drawing/2014/main" id="{25267CF1-48A3-4925-B2AE-FFBEC0F06F82}"/>
+                <a16:creationId xmlns:a16="http://schemas.microsoft.com/office/drawing/2014/main" id="{91887761-1312-44CB-82C8-01146253C6B1}"/>
               </a:ext>
             </a:extLst>
           </p:cNvPr>
@@ -7826,7 +7826,7 @@
           <p:cNvPr id="5" name="">
             <a:extLst xmlns:a="http://schemas.openxmlformats.org/drawingml/2006/main">
               <a:ext uri="{FF2B5EF4-FFF2-40B4-BE49-F238E27FC236}">
-                <a16:creationId xmlns:a16="http://schemas.microsoft.com/office/drawing/2014/main" id="{70BC8DB3-4352-48DA-BADD-C78D9E65E0E7}"/>
+                <a16:creationId xmlns:a16="http://schemas.microsoft.com/office/drawing/2014/main" id="{D726C246-69D1-4E76-892F-7456B1960F98}"/>
               </a:ext>
             </a:extLst>
           </p:cNvPr>
@@ -7908,7 +7908,7 @@
           <p:cNvPr id="6" name="">
             <a:extLst xmlns:a="http://schemas.openxmlformats.org/drawingml/2006/main">
               <a:ext uri="{FF2B5EF4-FFF2-40B4-BE49-F238E27FC236}">
-                <a16:creationId xmlns:a16="http://schemas.microsoft.com/office/drawing/2014/main" id="{9CCFCB1C-0C26-4C58-925A-58A4D7D60236}"/>
+                <a16:creationId xmlns:a16="http://schemas.microsoft.com/office/drawing/2014/main" id="{C1BEC05C-544E-446A-AFE0-8D630E62E9A0}"/>
               </a:ext>
             </a:extLst>
           </p:cNvPr>
@@ -7938,7 +7938,7 @@
           <p:cNvPr id="7" name="">
             <a:extLst xmlns:a="http://schemas.openxmlformats.org/drawingml/2006/main">
               <a:ext uri="{FF2B5EF4-FFF2-40B4-BE49-F238E27FC236}">
-                <a16:creationId xmlns:a16="http://schemas.microsoft.com/office/drawing/2014/main" id="{A138A4CC-137B-4AD6-92B5-972271FF958E}"/>
+                <a16:creationId xmlns:a16="http://schemas.microsoft.com/office/drawing/2014/main" id="{BA4B53A8-0F37-4B39-B6F3-9DFA0810E443}"/>
               </a:ext>
             </a:extLst>
           </p:cNvPr>
@@ -8020,7 +8020,7 @@
           <p:cNvPr id="8" name="">
             <a:extLst xmlns:a="http://schemas.openxmlformats.org/drawingml/2006/main">
               <a:ext uri="{FF2B5EF4-FFF2-40B4-BE49-F238E27FC236}">
-                <a16:creationId xmlns:a16="http://schemas.microsoft.com/office/drawing/2014/main" id="{EB65C76D-EBEF-44A0-8DAD-B4488EA94C64}"/>
+                <a16:creationId xmlns:a16="http://schemas.microsoft.com/office/drawing/2014/main" id="{13E9A1F5-D57F-4BF5-A7ED-A76164842552}"/>
               </a:ext>
             </a:extLst>
           </p:cNvPr>
@@ -8050,7 +8050,7 @@
           <p:cNvPr id="9" name="">
             <a:extLst xmlns:a="http://schemas.openxmlformats.org/drawingml/2006/main">
               <a:ext uri="{FF2B5EF4-FFF2-40B4-BE49-F238E27FC236}">
-                <a16:creationId xmlns:a16="http://schemas.microsoft.com/office/drawing/2014/main" id="{79CEEEF5-B047-4C41-867F-0229310E3122}"/>
+                <a16:creationId xmlns:a16="http://schemas.microsoft.com/office/drawing/2014/main" id="{CB5E22A9-CD32-409B-92A1-AB4D5C10F2AD}"/>
               </a:ext>
             </a:extLst>
           </p:cNvPr>
@@ -8132,7 +8132,7 @@
           <p:cNvPr id="10" name="">
             <a:extLst xmlns:a="http://schemas.openxmlformats.org/drawingml/2006/main">
               <a:ext uri="{FF2B5EF4-FFF2-40B4-BE49-F238E27FC236}">
-                <a16:creationId xmlns:a16="http://schemas.microsoft.com/office/drawing/2014/main" id="{D1BA57D1-2AE2-401F-8EC8-8DD4C079AA2F}"/>
+                <a16:creationId xmlns:a16="http://schemas.microsoft.com/office/drawing/2014/main" id="{20588C75-8853-48FE-92CB-07940CC38CA0}"/>
               </a:ext>
             </a:extLst>
           </p:cNvPr>
@@ -8189,7 +8189,7 @@
           <p:cNvPr id="11" name="">
             <a:extLst xmlns:a="http://schemas.openxmlformats.org/drawingml/2006/main">
               <a:ext uri="{FF2B5EF4-FFF2-40B4-BE49-F238E27FC236}">
-                <a16:creationId xmlns:a16="http://schemas.microsoft.com/office/drawing/2014/main" id="{8F572901-74C5-4458-ADB4-B88E8ED6BD0D}"/>
+                <a16:creationId xmlns:a16="http://schemas.microsoft.com/office/drawing/2014/main" id="{F9AFF6CE-F79E-4D18-84FB-42AFB451AAD2}"/>
               </a:ext>
             </a:extLst>
           </p:cNvPr>
@@ -8246,7 +8246,7 @@
           <p:cNvPr id="12" name="">
             <a:extLst xmlns:a="http://schemas.openxmlformats.org/drawingml/2006/main">
               <a:ext uri="{FF2B5EF4-FFF2-40B4-BE49-F238E27FC236}">
-                <a16:creationId xmlns:a16="http://schemas.microsoft.com/office/drawing/2014/main" id="{623BB8A5-580E-42BF-921A-9D6F730484B8}"/>
+                <a16:creationId xmlns:a16="http://schemas.microsoft.com/office/drawing/2014/main" id="{9B4EE41C-0178-42CD-9665-B489C1998C38}"/>
               </a:ext>
             </a:extLst>
           </p:cNvPr>
@@ -8301,7 +8301,7 @@
     </p:spTree>
     <p:extLst>
       <p:ext uri="{BB962C8B-B14F-4D97-AF65-F5344CB8AC3E}">
-        <p14:creationId xmlns:p14="http://schemas.microsoft.com/office/powerpoint/2010/main" val="1709090866"/>
+        <p14:creationId xmlns:p14="http://schemas.microsoft.com/office/powerpoint/2010/main" val="34154812"/>
       </p:ext>
     </p:extLst>
   </p:cSld>
@@ -8332,7 +8332,7 @@
           <p:cNvPr id="10" name="">
             <a:extLst xmlns:a="http://schemas.openxmlformats.org/drawingml/2006/main">
               <a:ext uri="{FF2B5EF4-FFF2-40B4-BE49-F238E27FC236}">
-                <a16:creationId xmlns:a16="http://schemas.microsoft.com/office/drawing/2014/main" id="{9854A320-4C2E-45B3-B080-60ED9BC35561}"/>
+                <a16:creationId xmlns:a16="http://schemas.microsoft.com/office/drawing/2014/main" id="{D15C2943-6A4A-4221-AD06-92890FC2A147}"/>
               </a:ext>
             </a:extLst>
           </p:cNvPr>
@@ -8389,7 +8389,7 @@
           <p:cNvPr id="2" name="">
             <a:extLst xmlns:a="http://schemas.openxmlformats.org/drawingml/2006/main">
               <a:ext uri="{FF2B5EF4-FFF2-40B4-BE49-F238E27FC236}">
-                <a16:creationId xmlns:a16="http://schemas.microsoft.com/office/drawing/2014/main" id="{F7A4C2F3-5C4C-400A-9595-D5721F46592E}"/>
+                <a16:creationId xmlns:a16="http://schemas.microsoft.com/office/drawing/2014/main" id="{A561D1A6-F5AC-427E-8332-46D17EAD70A3}"/>
               </a:ext>
             </a:extLst>
           </p:cNvPr>
@@ -8446,7 +8446,7 @@
           <p:cNvPr id="3" name="">
             <a:extLst xmlns:a="http://schemas.openxmlformats.org/drawingml/2006/main">
               <a:ext uri="{FF2B5EF4-FFF2-40B4-BE49-F238E27FC236}">
-                <a16:creationId xmlns:a16="http://schemas.microsoft.com/office/drawing/2014/main" id="{F5AAD6E3-3580-4D8A-91C5-858FB4DC13C7}"/>
+                <a16:creationId xmlns:a16="http://schemas.microsoft.com/office/drawing/2014/main" id="{04163B53-8FC6-4780-B596-B940F17BB514}"/>
               </a:ext>
             </a:extLst>
           </p:cNvPr>
@@ -8503,7 +8503,7 @@
           <p:cNvPr id="4" name="">
             <a:extLst xmlns:a="http://schemas.openxmlformats.org/drawingml/2006/main">
               <a:ext uri="{FF2B5EF4-FFF2-40B4-BE49-F238E27FC236}">
-                <a16:creationId xmlns:a16="http://schemas.microsoft.com/office/drawing/2014/main" id="{136882A3-A99A-4B78-AACD-EB9B019E763B}"/>
+                <a16:creationId xmlns:a16="http://schemas.microsoft.com/office/drawing/2014/main" id="{CCAC98D8-65C7-47AC-92D7-915A032159CB}"/>
               </a:ext>
             </a:extLst>
           </p:cNvPr>
@@ -8560,7 +8560,7 @@
           <p:cNvPr id="5" name="">
             <a:extLst xmlns:a="http://schemas.openxmlformats.org/drawingml/2006/main">
               <a:ext uri="{FF2B5EF4-FFF2-40B4-BE49-F238E27FC236}">
-                <a16:creationId xmlns:a16="http://schemas.microsoft.com/office/drawing/2014/main" id="{564B719E-6D4C-477A-9F67-7B180C9E697F}"/>
+                <a16:creationId xmlns:a16="http://schemas.microsoft.com/office/drawing/2014/main" id="{4C174CFE-F44A-4D13-8B1D-232A4FC4F462}"/>
               </a:ext>
             </a:extLst>
           </p:cNvPr>
@@ -8617,7 +8617,7 @@
           <p:cNvPr id="6" name="">
             <a:extLst xmlns:a="http://schemas.openxmlformats.org/drawingml/2006/main">
               <a:ext uri="{FF2B5EF4-FFF2-40B4-BE49-F238E27FC236}">
-                <a16:creationId xmlns:a16="http://schemas.microsoft.com/office/drawing/2014/main" id="{538BD367-66D9-4581-80B8-68214F7EAAEC}"/>
+                <a16:creationId xmlns:a16="http://schemas.microsoft.com/office/drawing/2014/main" id="{592026B1-9C49-4924-818B-093FEB1FA538}"/>
               </a:ext>
             </a:extLst>
           </p:cNvPr>
@@ -8674,7 +8674,7 @@
           <p:cNvPr id="7" name="">
             <a:extLst xmlns:a="http://schemas.openxmlformats.org/drawingml/2006/main">
               <a:ext uri="{FF2B5EF4-FFF2-40B4-BE49-F238E27FC236}">
-                <a16:creationId xmlns:a16="http://schemas.microsoft.com/office/drawing/2014/main" id="{266B4651-3249-48E1-91D1-EF9BF306D65A}"/>
+                <a16:creationId xmlns:a16="http://schemas.microsoft.com/office/drawing/2014/main" id="{1880EC1E-C79C-4564-9224-96AE7CC78184}"/>
               </a:ext>
             </a:extLst>
           </p:cNvPr>
@@ -8731,7 +8731,7 @@
           <p:cNvPr id="8" name="">
             <a:extLst xmlns:a="http://schemas.openxmlformats.org/drawingml/2006/main">
               <a:ext uri="{FF2B5EF4-FFF2-40B4-BE49-F238E27FC236}">
-                <a16:creationId xmlns:a16="http://schemas.microsoft.com/office/drawing/2014/main" id="{8491C1C7-31E7-4702-BF97-7974D0F7950A}"/>
+                <a16:creationId xmlns:a16="http://schemas.microsoft.com/office/drawing/2014/main" id="{156FD306-F229-41D5-9580-48D37255B219}"/>
               </a:ext>
             </a:extLst>
           </p:cNvPr>
@@ -8788,7 +8788,7 @@
           <p:cNvPr id="9" name="">
             <a:extLst xmlns:a="http://schemas.openxmlformats.org/drawingml/2006/main">
               <a:ext uri="{FF2B5EF4-FFF2-40B4-BE49-F238E27FC236}">
-                <a16:creationId xmlns:a16="http://schemas.microsoft.com/office/drawing/2014/main" id="{01D0DB54-B601-4499-B337-6AB0F3CE61B9}"/>
+                <a16:creationId xmlns:a16="http://schemas.microsoft.com/office/drawing/2014/main" id="{BF8F758D-0577-4F62-B8EC-CEAFB9A12317}"/>
               </a:ext>
             </a:extLst>
           </p:cNvPr>
@@ -8843,7 +8843,7 @@
     </p:spTree>
     <p:extLst>
       <p:ext uri="{BB962C8B-B14F-4D97-AF65-F5344CB8AC3E}">
-        <p14:creationId xmlns:p14="http://schemas.microsoft.com/office/powerpoint/2010/main" val="2085710026"/>
+        <p14:creationId xmlns:p14="http://schemas.microsoft.com/office/powerpoint/2010/main" val="314176501"/>
       </p:ext>
     </p:extLst>
   </p:cSld>
@@ -8874,7 +8874,7 @@
           <p:cNvPr id="10" name="">
             <a:extLst xmlns:a="http://schemas.openxmlformats.org/drawingml/2006/main">
               <a:ext uri="{FF2B5EF4-FFF2-40B4-BE49-F238E27FC236}">
-                <a16:creationId xmlns:a16="http://schemas.microsoft.com/office/drawing/2014/main" id="{F4F2905E-6C92-4DDD-B3AE-571199ECC1BF}"/>
+                <a16:creationId xmlns:a16="http://schemas.microsoft.com/office/drawing/2014/main" id="{4B8351A6-C211-479D-B022-472E5FC96923}"/>
               </a:ext>
             </a:extLst>
           </p:cNvPr>
@@ -8931,7 +8931,7 @@
           <p:cNvPr id="2" name="">
             <a:extLst xmlns:a="http://schemas.openxmlformats.org/drawingml/2006/main">
               <a:ext uri="{FF2B5EF4-FFF2-40B4-BE49-F238E27FC236}">
-                <a16:creationId xmlns:a16="http://schemas.microsoft.com/office/drawing/2014/main" id="{6C9A2C23-2DD0-4445-B71D-95BA1DD4143C}"/>
+                <a16:creationId xmlns:a16="http://schemas.microsoft.com/office/drawing/2014/main" id="{89F082AA-68D8-49E6-A923-AAD4BA4226F2}"/>
               </a:ext>
             </a:extLst>
           </p:cNvPr>
@@ -8988,7 +8988,7 @@
           <p:cNvPr id="3" name="">
             <a:extLst xmlns:a="http://schemas.openxmlformats.org/drawingml/2006/main">
               <a:ext uri="{FF2B5EF4-FFF2-40B4-BE49-F238E27FC236}">
-                <a16:creationId xmlns:a16="http://schemas.microsoft.com/office/drawing/2014/main" id="{32E00378-1560-4DE1-8942-934A9ADEFF91}"/>
+                <a16:creationId xmlns:a16="http://schemas.microsoft.com/office/drawing/2014/main" id="{0328B6D3-62AD-441B-B02F-0A18640B08EA}"/>
               </a:ext>
             </a:extLst>
           </p:cNvPr>
@@ -9045,7 +9045,7 @@
           <p:cNvPr id="4" name="">
             <a:extLst xmlns:a="http://schemas.openxmlformats.org/drawingml/2006/main">
               <a:ext uri="{FF2B5EF4-FFF2-40B4-BE49-F238E27FC236}">
-                <a16:creationId xmlns:a16="http://schemas.microsoft.com/office/drawing/2014/main" id="{30D8099E-15F6-4AD5-B51E-76E91429F632}"/>
+                <a16:creationId xmlns:a16="http://schemas.microsoft.com/office/drawing/2014/main" id="{BCEFD5A0-344F-4D51-8BF2-D8999DBB9B74}"/>
               </a:ext>
             </a:extLst>
           </p:cNvPr>
@@ -9102,7 +9102,7 @@
           <p:cNvPr id="5" name="">
             <a:extLst xmlns:a="http://schemas.openxmlformats.org/drawingml/2006/main">
               <a:ext uri="{FF2B5EF4-FFF2-40B4-BE49-F238E27FC236}">
-                <a16:creationId xmlns:a16="http://schemas.microsoft.com/office/drawing/2014/main" id="{D4DD83F5-70A7-49EC-91CA-75827FD5758F}"/>
+                <a16:creationId xmlns:a16="http://schemas.microsoft.com/office/drawing/2014/main" id="{180FF683-9EE7-4263-AEC7-582330D2A7D1}"/>
               </a:ext>
             </a:extLst>
           </p:cNvPr>
@@ -9159,7 +9159,7 @@
           <p:cNvPr id="6" name="">
             <a:extLst xmlns:a="http://schemas.openxmlformats.org/drawingml/2006/main">
               <a:ext uri="{FF2B5EF4-FFF2-40B4-BE49-F238E27FC236}">
-                <a16:creationId xmlns:a16="http://schemas.microsoft.com/office/drawing/2014/main" id="{780D3729-63EB-4B65-85C3-A37D1A9A41B5}"/>
+                <a16:creationId xmlns:a16="http://schemas.microsoft.com/office/drawing/2014/main" id="{A256216E-5C34-42FD-A515-8DC8EC3092E6}"/>
               </a:ext>
             </a:extLst>
           </p:cNvPr>
@@ -9216,7 +9216,7 @@
           <p:cNvPr id="7" name="">
             <a:extLst xmlns:a="http://schemas.openxmlformats.org/drawingml/2006/main">
               <a:ext uri="{FF2B5EF4-FFF2-40B4-BE49-F238E27FC236}">
-                <a16:creationId xmlns:a16="http://schemas.microsoft.com/office/drawing/2014/main" id="{0A370924-88A3-42F9-8457-D5D3B48CCA76}"/>
+                <a16:creationId xmlns:a16="http://schemas.microsoft.com/office/drawing/2014/main" id="{0FDE0AB4-4FD7-4CAA-87A7-3C8B554297C0}"/>
               </a:ext>
             </a:extLst>
           </p:cNvPr>
@@ -9273,7 +9273,7 @@
           <p:cNvPr id="8" name="">
             <a:extLst xmlns:a="http://schemas.openxmlformats.org/drawingml/2006/main">
               <a:ext uri="{FF2B5EF4-FFF2-40B4-BE49-F238E27FC236}">
-                <a16:creationId xmlns:a16="http://schemas.microsoft.com/office/drawing/2014/main" id="{6E284E8D-639A-45BB-A50F-F3BFB1CB87C2}"/>
+                <a16:creationId xmlns:a16="http://schemas.microsoft.com/office/drawing/2014/main" id="{7B38B496-DA84-445C-BCDC-C9CD7362E5E1}"/>
               </a:ext>
             </a:extLst>
           </p:cNvPr>
@@ -9320,7 +9320,7 @@
                 <a:ea typeface="Apple SD Gothic Neo"/>
                 <a:cs typeface="Apple SD Gothic Neo"/>
               </a:rPr>
-              <a:t>scripted QM SIT 6건 통과. 현재 native QM은 검사 제안 전 실행 실패로 FAIL이다.</a:t>
+              <a:t>scripted QM SIT 6건 통과. native QM은 QC PENDING·HOLD·잔량 2·적용 0으로 PASS다.</a:t>
             </a:r>
           </a:p>
         </p:txBody>
@@ -9330,7 +9330,7 @@
           <p:cNvPr id="9" name="">
             <a:extLst xmlns:a="http://schemas.openxmlformats.org/drawingml/2006/main">
               <a:ext uri="{FF2B5EF4-FFF2-40B4-BE49-F238E27FC236}">
-                <a16:creationId xmlns:a16="http://schemas.microsoft.com/office/drawing/2014/main" id="{DA25F96D-7612-4C75-9DA1-94A83F97A9DC}"/>
+                <a16:creationId xmlns:a16="http://schemas.microsoft.com/office/drawing/2014/main" id="{62B8EBFD-D8DB-4E7F-A973-12D2596BEAF1}"/>
               </a:ext>
             </a:extLst>
           </p:cNvPr>
@@ -9385,7 +9385,7 @@
     </p:spTree>
     <p:extLst>
       <p:ext uri="{BB962C8B-B14F-4D97-AF65-F5344CB8AC3E}">
-        <p14:creationId xmlns:p14="http://schemas.microsoft.com/office/powerpoint/2010/main" val="488552968"/>
+        <p14:creationId xmlns:p14="http://schemas.microsoft.com/office/powerpoint/2010/main" val="1171432618"/>
       </p:ext>
     </p:extLst>
   </p:cSld>
@@ -9416,7 +9416,7 @@
           <p:cNvPr id="5" name="">
             <a:extLst xmlns:a="http://schemas.openxmlformats.org/drawingml/2006/main">
               <a:ext uri="{FF2B5EF4-FFF2-40B4-BE49-F238E27FC236}">
-                <a16:creationId xmlns:a16="http://schemas.microsoft.com/office/drawing/2014/main" id="{2E7C77DF-1999-4060-88B5-21E697D59724}"/>
+                <a16:creationId xmlns:a16="http://schemas.microsoft.com/office/drawing/2014/main" id="{0617BEDC-7558-404D-9D66-CDB025A7F74A}"/>
               </a:ext>
             </a:extLst>
           </p:cNvPr>
@@ -9473,7 +9473,7 @@
           <p:cNvPr id="2" name="">
             <a:extLst xmlns:a="http://schemas.openxmlformats.org/drawingml/2006/main">
               <a:ext uri="{FF2B5EF4-FFF2-40B4-BE49-F238E27FC236}">
-                <a16:creationId xmlns:a16="http://schemas.microsoft.com/office/drawing/2014/main" id="{C0A546F5-757F-4AD5-A502-38D929557CBF}"/>
+                <a16:creationId xmlns:a16="http://schemas.microsoft.com/office/drawing/2014/main" id="{0B86320F-A2BD-4FB7-A693-B7796AE050CD}"/>
               </a:ext>
             </a:extLst>
           </p:cNvPr>
@@ -9997,7 +9997,7 @@
           <p:cNvPr id="4" name="">
             <a:extLst xmlns:a="http://schemas.openxmlformats.org/drawingml/2006/main">
               <a:ext uri="{FF2B5EF4-FFF2-40B4-BE49-F238E27FC236}">
-                <a16:creationId xmlns:a16="http://schemas.microsoft.com/office/drawing/2014/main" id="{091A4895-EF6E-473F-A1CA-240E21CE893A}"/>
+                <a16:creationId xmlns:a16="http://schemas.microsoft.com/office/drawing/2014/main" id="{D136555B-3C39-46B4-8C47-856720892818}"/>
               </a:ext>
             </a:extLst>
           </p:cNvPr>
@@ -10052,7 +10052,7 @@
     </p:spTree>
     <p:extLst>
       <p:ext uri="{BB962C8B-B14F-4D97-AF65-F5344CB8AC3E}">
-        <p14:creationId xmlns:p14="http://schemas.microsoft.com/office/powerpoint/2010/main" val="1058758076"/>
+        <p14:creationId xmlns:p14="http://schemas.microsoft.com/office/powerpoint/2010/main" val="598373609"/>
       </p:ext>
     </p:extLst>
   </p:cSld>
@@ -10083,7 +10083,7 @@
           <p:cNvPr id="10" name="">
             <a:extLst xmlns:a="http://schemas.openxmlformats.org/drawingml/2006/main">
               <a:ext uri="{FF2B5EF4-FFF2-40B4-BE49-F238E27FC236}">
-                <a16:creationId xmlns:a16="http://schemas.microsoft.com/office/drawing/2014/main" id="{7620F1E7-1DB1-47EC-B36E-E109C228D4F3}"/>
+                <a16:creationId xmlns:a16="http://schemas.microsoft.com/office/drawing/2014/main" id="{7812275E-2527-4B94-A19C-DFA34A2F8C0A}"/>
               </a:ext>
             </a:extLst>
           </p:cNvPr>
@@ -10140,7 +10140,7 @@
           <p:cNvPr id="2" name="">
             <a:extLst xmlns:a="http://schemas.openxmlformats.org/drawingml/2006/main">
               <a:ext uri="{FF2B5EF4-FFF2-40B4-BE49-F238E27FC236}">
-                <a16:creationId xmlns:a16="http://schemas.microsoft.com/office/drawing/2014/main" id="{1AAE5189-5922-48A6-874A-FAD225185731}"/>
+                <a16:creationId xmlns:a16="http://schemas.microsoft.com/office/drawing/2014/main" id="{C87089CC-877C-4DD0-B13A-DA3A573D0A79}"/>
               </a:ext>
             </a:extLst>
           </p:cNvPr>
@@ -10197,7 +10197,7 @@
           <p:cNvPr id="3" name="">
             <a:extLst xmlns:a="http://schemas.openxmlformats.org/drawingml/2006/main">
               <a:ext uri="{FF2B5EF4-FFF2-40B4-BE49-F238E27FC236}">
-                <a16:creationId xmlns:a16="http://schemas.microsoft.com/office/drawing/2014/main" id="{4C047F3E-7017-4145-B5A7-6B1D416E9644}"/>
+                <a16:creationId xmlns:a16="http://schemas.microsoft.com/office/drawing/2014/main" id="{8EB19811-B36F-4D4F-BF8B-5DCA5856EF22}"/>
               </a:ext>
             </a:extLst>
           </p:cNvPr>
@@ -10254,7 +10254,7 @@
           <p:cNvPr id="4" name="">
             <a:extLst xmlns:a="http://schemas.openxmlformats.org/drawingml/2006/main">
               <a:ext uri="{FF2B5EF4-FFF2-40B4-BE49-F238E27FC236}">
-                <a16:creationId xmlns:a16="http://schemas.microsoft.com/office/drawing/2014/main" id="{4D6B527B-58F5-49D9-945B-915C2B335877}"/>
+                <a16:creationId xmlns:a16="http://schemas.microsoft.com/office/drawing/2014/main" id="{1CF556EE-3E3B-4636-B6E5-04AD6A7F68E4}"/>
               </a:ext>
             </a:extLst>
           </p:cNvPr>
@@ -10311,7 +10311,7 @@
           <p:cNvPr id="5" name="">
             <a:extLst xmlns:a="http://schemas.openxmlformats.org/drawingml/2006/main">
               <a:ext uri="{FF2B5EF4-FFF2-40B4-BE49-F238E27FC236}">
-                <a16:creationId xmlns:a16="http://schemas.microsoft.com/office/drawing/2014/main" id="{68C8F805-C4A0-4A06-A93E-CC9BCF74FFCD}"/>
+                <a16:creationId xmlns:a16="http://schemas.microsoft.com/office/drawing/2014/main" id="{095D13A1-1C0E-4605-9CAD-0EE148D59D45}"/>
               </a:ext>
             </a:extLst>
           </p:cNvPr>
@@ -10368,7 +10368,7 @@
           <p:cNvPr id="6" name="">
             <a:extLst xmlns:a="http://schemas.openxmlformats.org/drawingml/2006/main">
               <a:ext uri="{FF2B5EF4-FFF2-40B4-BE49-F238E27FC236}">
-                <a16:creationId xmlns:a16="http://schemas.microsoft.com/office/drawing/2014/main" id="{F5695888-8B0B-4EDF-A485-021B13BB82AC}"/>
+                <a16:creationId xmlns:a16="http://schemas.microsoft.com/office/drawing/2014/main" id="{7C8D6116-8200-4C5B-97FF-9EE0874E2F84}"/>
               </a:ext>
             </a:extLst>
           </p:cNvPr>
@@ -10425,7 +10425,7 @@
           <p:cNvPr id="7" name="">
             <a:extLst xmlns:a="http://schemas.openxmlformats.org/drawingml/2006/main">
               <a:ext uri="{FF2B5EF4-FFF2-40B4-BE49-F238E27FC236}">
-                <a16:creationId xmlns:a16="http://schemas.microsoft.com/office/drawing/2014/main" id="{1F3EFDB3-5E0A-4A94-B887-FCCC85480500}"/>
+                <a16:creationId xmlns:a16="http://schemas.microsoft.com/office/drawing/2014/main" id="{76BD3574-AF4D-4078-BF30-658048FB17FE}"/>
               </a:ext>
             </a:extLst>
           </p:cNvPr>
@@ -10482,7 +10482,7 @@
           <p:cNvPr id="8" name="">
             <a:extLst xmlns:a="http://schemas.openxmlformats.org/drawingml/2006/main">
               <a:ext uri="{FF2B5EF4-FFF2-40B4-BE49-F238E27FC236}">
-                <a16:creationId xmlns:a16="http://schemas.microsoft.com/office/drawing/2014/main" id="{AC8E32BF-3908-44F3-8967-BBB1CD95E625}"/>
+                <a16:creationId xmlns:a16="http://schemas.microsoft.com/office/drawing/2014/main" id="{D409FD9D-E5A4-41DB-9699-4FC69E38A72E}"/>
               </a:ext>
             </a:extLst>
           </p:cNvPr>
@@ -10539,7 +10539,7 @@
           <p:cNvPr id="9" name="">
             <a:extLst xmlns:a="http://schemas.openxmlformats.org/drawingml/2006/main">
               <a:ext uri="{FF2B5EF4-FFF2-40B4-BE49-F238E27FC236}">
-                <a16:creationId xmlns:a16="http://schemas.microsoft.com/office/drawing/2014/main" id="{65175AC6-612E-4742-A3BE-FEEA2859B8D8}"/>
+                <a16:creationId xmlns:a16="http://schemas.microsoft.com/office/drawing/2014/main" id="{2EE63FE0-03B8-44B9-A698-708A223ECB1E}"/>
               </a:ext>
             </a:extLst>
           </p:cNvPr>
@@ -10594,7 +10594,7 @@
     </p:spTree>
     <p:extLst>
       <p:ext uri="{BB962C8B-B14F-4D97-AF65-F5344CB8AC3E}">
-        <p14:creationId xmlns:p14="http://schemas.microsoft.com/office/powerpoint/2010/main" val="1218435796"/>
+        <p14:creationId xmlns:p14="http://schemas.microsoft.com/office/powerpoint/2010/main" val="2114186799"/>
       </p:ext>
     </p:extLst>
   </p:cSld>

</xml_diff>